<commit_message>
Add Platt scaling, sample-size sweep, error bars, practical takeaway
- Platt (sigmoid) recalibration added to run_robustness.py alongside isotonic
- All tables updated with mean±std error bars and Platt column
- Sample-size sweep (5%,10%,20%,50%) with new F_Sample_Sweep figure
- Paper updated: practical takeaway paragraph, sweep figure, Platt discussion
- PPTX rebuilt with 14 slides including new sweep slide
- README updated with new scripts and findings
</commit_message>
<xml_diff>
--- a/opendesign/mockups/conference-b-deck/robustness_presentation.pptx
+++ b/opendesign/mockups/conference-b-deck/robustness_presentation.pptx
@@ -18,6 +18,7 @@
     <p:sldId id="266" r:id="rId17"/>
     <p:sldId id="267" r:id="rId18"/>
     <p:sldId id="268" r:id="rId19"/>
+    <p:sldId id="269" r:id="rId20"/>
   </p:sldIdLst>
   <p:sldSz cx="12192000" cy="6858000" type="screen4x3"/>
   <p:notesSz cx="6858000" cy="9144000"/>
@@ -3298,7 +3299,7 @@
               </a:defRPr>
             </a:pPr>
             <a:r>
-              <a:t>1 / 11</a:t>
+              <a:t>1 / 14</a:t>
             </a:r>
           </a:p>
         </p:txBody>
@@ -3452,8 +3453,8 @@
         </p:nvSpPr>
         <p:spPr>
           <a:xfrm>
-            <a:off x="731520" y="1188720"/>
-            <a:ext cx="4754880" cy="365760"/>
+            <a:off x="731520" y="914400"/>
+            <a:ext cx="4754880" cy="457200"/>
           </a:xfrm>
           <a:prstGeom prst="rect">
             <a:avLst/>
@@ -3467,7 +3468,7 @@
           <a:lstStyle/>
           <a:p>
             <a:pPr algn="l">
-              <a:defRPr sz="1600" b="0">
+              <a:defRPr sz="1500" b="0">
                 <a:solidFill>
                   <a:srgbClr val="1E293B"/>
                 </a:solidFill>
@@ -3475,7 +3476,7 @@
               </a:defRPr>
             </a:pPr>
             <a:r>
-              <a:t>Isotonic regression fit on 10%, evaluated on held-out 90%:</a:t>
+              <a:t>Both isotonic and Platt recalibration recover calibration. Mean±std across 5 seeds × 4 severities:</a:t>
             </a:r>
           </a:p>
         </p:txBody>
@@ -3489,8 +3490,8 @@
           <p:nvPr/>
         </p:nvGraphicFramePr>
         <p:xfrm>
-          <a:off x="731520" y="1737360"/>
-          <a:ext cx="4754880" cy="2286000"/>
+          <a:off x="731520" y="1554480"/>
+          <a:ext cx="5669280" cy="2286000"/>
         </p:xfrm>
         <a:graphic>
           <a:graphicData uri="http://schemas.openxmlformats.org/drawingml/2006/table">
@@ -3499,10 +3500,11 @@
                 <a:tableStyleId>{5C22544A-7EE6-4342-B048-85BDC9FD1C3A}</a:tableStyleId>
               </a:tblPr>
               <a:tblGrid>
-                <a:gridCol w="1188720"/>
-                <a:gridCol w="1188720"/>
-                <a:gridCol w="1188720"/>
-                <a:gridCol w="1188720"/>
+                <a:gridCol w="1133856"/>
+                <a:gridCol w="1133856"/>
+                <a:gridCol w="1133856"/>
+                <a:gridCol w="1133856"/>
+                <a:gridCol w="1133856"/>
               </a:tblGrid>
               <a:tr h="457200">
                 <a:tc>
@@ -3511,7 +3513,7 @@
                     <a:lstStyle/>
                     <a:p>
                       <a:pPr>
-                        <a:defRPr sz="1300" b="1">
+                        <a:defRPr sz="1200" b="1">
                           <a:solidFill>
                             <a:srgbClr val="0F172A"/>
                           </a:solidFill>
@@ -3531,7 +3533,7 @@
                     <a:lstStyle/>
                     <a:p>
                       <a:pPr>
-                        <a:defRPr sz="1300" b="1">
+                        <a:defRPr sz="1200" b="1">
                           <a:solidFill>
                             <a:srgbClr val="0F172A"/>
                           </a:solidFill>
@@ -3551,7 +3553,7 @@
                     <a:lstStyle/>
                     <a:p>
                       <a:pPr>
-                        <a:defRPr sz="1300" b="1">
+                        <a:defRPr sz="1200" b="1">
                           <a:solidFill>
                             <a:srgbClr val="0F172A"/>
                           </a:solidFill>
@@ -3571,7 +3573,7 @@
                     <a:lstStyle/>
                     <a:p>
                       <a:pPr>
-                        <a:defRPr sz="1300" b="1">
+                        <a:defRPr sz="1200" b="1">
                           <a:solidFill>
                             <a:srgbClr val="0F172A"/>
                           </a:solidFill>
@@ -3579,7 +3581,27 @@
                         </a:defRPr>
                       </a:pPr>
                       <a:r>
-                        <a:t>Recalibrated</a:t>
+                        <a:t>Isotonic</a:t>
+                      </a:r>
+                    </a:p>
+                  </a:txBody>
+                  <a:tcPr/>
+                </a:tc>
+                <a:tc>
+                  <a:txBody>
+                    <a:bodyPr/>
+                    <a:lstStyle/>
+                    <a:p>
+                      <a:pPr>
+                        <a:defRPr sz="1200" b="1">
+                          <a:solidFill>
+                            <a:srgbClr val="0F172A"/>
+                          </a:solidFill>
+                          <a:latin typeface="Calibri"/>
+                        </a:defRPr>
+                      </a:pPr>
+                      <a:r>
+                        <a:t>Platt</a:t>
                       </a:r>
                     </a:p>
                   </a:txBody>
@@ -3593,7 +3615,7 @@
                     <a:lstStyle/>
                     <a:p>
                       <a:pPr>
-                        <a:defRPr sz="1300">
+                        <a:defRPr sz="1200">
                           <a:solidFill>
                             <a:srgbClr val="1E293B"/>
                           </a:solidFill>
@@ -3613,7 +3635,7 @@
                     <a:lstStyle/>
                     <a:p>
                       <a:pPr>
-                        <a:defRPr sz="1300">
+                        <a:defRPr sz="1200">
                           <a:solidFill>
                             <a:srgbClr val="1E293B"/>
                           </a:solidFill>
@@ -3633,7 +3655,7 @@
                     <a:lstStyle/>
                     <a:p>
                       <a:pPr>
-                        <a:defRPr sz="1300">
+                        <a:defRPr sz="1200">
                           <a:solidFill>
                             <a:srgbClr val="1E293B"/>
                           </a:solidFill>
@@ -3641,7 +3663,7 @@
                         </a:defRPr>
                       </a:pPr>
                       <a:r>
-                        <a:t>0.272–0.313</a:t>
+                        <a:t>0.297±0.017</a:t>
                       </a:r>
                     </a:p>
                   </a:txBody>
@@ -3653,7 +3675,7 @@
                     <a:lstStyle/>
                     <a:p>
                       <a:pPr>
-                        <a:defRPr sz="1300" b="1">
+                        <a:defRPr sz="1200" b="1">
                           <a:solidFill>
                             <a:srgbClr val="16A34A"/>
                           </a:solidFill>
@@ -3661,7 +3683,27 @@
                         </a:defRPr>
                       </a:pPr>
                       <a:r>
-                        <a:t>0.057–0.076</a:t>
+                        <a:t>0.067±0.022</a:t>
+                      </a:r>
+                    </a:p>
+                  </a:txBody>
+                  <a:tcPr/>
+                </a:tc>
+                <a:tc>
+                  <a:txBody>
+                    <a:bodyPr/>
+                    <a:lstStyle/>
+                    <a:p>
+                      <a:pPr>
+                        <a:defRPr sz="1200" b="1">
+                          <a:solidFill>
+                            <a:srgbClr val="16A34A"/>
+                          </a:solidFill>
+                          <a:latin typeface="Calibri"/>
+                        </a:defRPr>
+                      </a:pPr>
+                      <a:r>
+                        <a:t>0.064±0.013</a:t>
                       </a:r>
                     </a:p>
                   </a:txBody>
@@ -3675,7 +3717,7 @@
                     <a:lstStyle/>
                     <a:p>
                       <a:pPr>
-                        <a:defRPr sz="1300">
+                        <a:defRPr sz="1200">
                           <a:solidFill>
                             <a:srgbClr val="1E293B"/>
                           </a:solidFill>
@@ -3695,7 +3737,7 @@
                     <a:lstStyle/>
                     <a:p>
                       <a:pPr>
-                        <a:defRPr sz="1300">
+                        <a:defRPr sz="1200">
                           <a:solidFill>
                             <a:srgbClr val="1E293B"/>
                           </a:solidFill>
@@ -3715,7 +3757,7 @@
                     <a:lstStyle/>
                     <a:p>
                       <a:pPr>
-                        <a:defRPr sz="1300">
+                        <a:defRPr sz="1200">
                           <a:solidFill>
                             <a:srgbClr val="1E293B"/>
                           </a:solidFill>
@@ -3723,7 +3765,7 @@
                         </a:defRPr>
                       </a:pPr>
                       <a:r>
-                        <a:t>0.277–0.293</a:t>
+                        <a:t>0.286±0.012</a:t>
                       </a:r>
                     </a:p>
                   </a:txBody>
@@ -3735,7 +3777,7 @@
                     <a:lstStyle/>
                     <a:p>
                       <a:pPr>
-                        <a:defRPr sz="1300" b="1">
+                        <a:defRPr sz="1200" b="1">
                           <a:solidFill>
                             <a:srgbClr val="16A34A"/>
                           </a:solidFill>
@@ -3743,7 +3785,27 @@
                         </a:defRPr>
                       </a:pPr>
                       <a:r>
-                        <a:t>0.060–0.073</a:t>
+                        <a:t>0.067±0.027</a:t>
+                      </a:r>
+                    </a:p>
+                  </a:txBody>
+                  <a:tcPr/>
+                </a:tc>
+                <a:tc>
+                  <a:txBody>
+                    <a:bodyPr/>
+                    <a:lstStyle/>
+                    <a:p>
+                      <a:pPr>
+                        <a:defRPr sz="1200" b="1">
+                          <a:solidFill>
+                            <a:srgbClr val="16A34A"/>
+                          </a:solidFill>
+                          <a:latin typeface="Calibri"/>
+                        </a:defRPr>
+                      </a:pPr>
+                      <a:r>
+                        <a:t>0.083±0.037</a:t>
                       </a:r>
                     </a:p>
                   </a:txBody>
@@ -3757,7 +3819,7 @@
                     <a:lstStyle/>
                     <a:p>
                       <a:pPr>
-                        <a:defRPr sz="1300">
+                        <a:defRPr sz="1200">
                           <a:solidFill>
                             <a:srgbClr val="1E293B"/>
                           </a:solidFill>
@@ -3777,7 +3839,7 @@
                     <a:lstStyle/>
                     <a:p>
                       <a:pPr>
-                        <a:defRPr sz="1300">
+                        <a:defRPr sz="1200">
                           <a:solidFill>
                             <a:srgbClr val="1E293B"/>
                           </a:solidFill>
@@ -3797,7 +3859,7 @@
                     <a:lstStyle/>
                     <a:p>
                       <a:pPr>
-                        <a:defRPr sz="1300">
+                        <a:defRPr sz="1200">
                           <a:solidFill>
                             <a:srgbClr val="1E293B"/>
                           </a:solidFill>
@@ -3805,7 +3867,7 @@
                         </a:defRPr>
                       </a:pPr>
                       <a:r>
-                        <a:t>0.288–0.316</a:t>
+                        <a:t>0.299±0.014</a:t>
                       </a:r>
                     </a:p>
                   </a:txBody>
@@ -3817,7 +3879,7 @@
                     <a:lstStyle/>
                     <a:p>
                       <a:pPr>
-                        <a:defRPr sz="1300" b="1">
+                        <a:defRPr sz="1200" b="1">
                           <a:solidFill>
                             <a:srgbClr val="16A34A"/>
                           </a:solidFill>
@@ -3825,7 +3887,27 @@
                         </a:defRPr>
                       </a:pPr>
                       <a:r>
-                        <a:t>0.076–0.092</a:t>
+                        <a:t>0.081±0.024</a:t>
+                      </a:r>
+                    </a:p>
+                  </a:txBody>
+                  <a:tcPr/>
+                </a:tc>
+                <a:tc>
+                  <a:txBody>
+                    <a:bodyPr/>
+                    <a:lstStyle/>
+                    <a:p>
+                      <a:pPr>
+                        <a:defRPr sz="1200" b="1">
+                          <a:solidFill>
+                            <a:srgbClr val="16A34A"/>
+                          </a:solidFill>
+                          <a:latin typeface="Calibri"/>
+                        </a:defRPr>
+                      </a:pPr>
+                      <a:r>
+                        <a:t>0.079±0.036</a:t>
                       </a:r>
                     </a:p>
                   </a:txBody>
@@ -3839,7 +3921,7 @@
                     <a:lstStyle/>
                     <a:p>
                       <a:pPr>
-                        <a:defRPr sz="1300">
+                        <a:defRPr sz="1200">
                           <a:solidFill>
                             <a:srgbClr val="1E293B"/>
                           </a:solidFill>
@@ -3859,7 +3941,7 @@
                     <a:lstStyle/>
                     <a:p>
                       <a:pPr>
-                        <a:defRPr sz="1300">
+                        <a:defRPr sz="1200">
                           <a:solidFill>
                             <a:srgbClr val="1E293B"/>
                           </a:solidFill>
@@ -3879,7 +3961,7 @@
                     <a:lstStyle/>
                     <a:p>
                       <a:pPr>
-                        <a:defRPr sz="1300">
+                        <a:defRPr sz="1200">
                           <a:solidFill>
                             <a:srgbClr val="1E293B"/>
                           </a:solidFill>
@@ -3887,7 +3969,7 @@
                         </a:defRPr>
                       </a:pPr>
                       <a:r>
-                        <a:t>0.331–0.381</a:t>
+                        <a:t>0.362±0.022</a:t>
                       </a:r>
                     </a:p>
                   </a:txBody>
@@ -3899,7 +3981,7 @@
                     <a:lstStyle/>
                     <a:p>
                       <a:pPr>
-                        <a:defRPr sz="1300" b="1">
+                        <a:defRPr sz="1200" b="1">
                           <a:solidFill>
                             <a:srgbClr val="16A34A"/>
                           </a:solidFill>
@@ -3907,7 +3989,27 @@
                         </a:defRPr>
                       </a:pPr>
                       <a:r>
-                        <a:t>0.080–0.094</a:t>
+                        <a:t>0.086±0.028</a:t>
+                      </a:r>
+                    </a:p>
+                  </a:txBody>
+                  <a:tcPr/>
+                </a:tc>
+                <a:tc>
+                  <a:txBody>
+                    <a:bodyPr/>
+                    <a:lstStyle/>
+                    <a:p>
+                      <a:pPr>
+                        <a:defRPr sz="1200" b="1">
+                          <a:solidFill>
+                            <a:srgbClr val="16A34A"/>
+                          </a:solidFill>
+                          <a:latin typeface="Calibri"/>
+                        </a:defRPr>
+                      </a:pPr>
+                      <a:r>
+                        <a:t>0.076±0.036</a:t>
                       </a:r>
                     </a:p>
                   </a:txBody>
@@ -3927,7 +4029,7 @@
         <p:spPr>
           <a:xfrm>
             <a:off x="731520" y="4114800"/>
-            <a:ext cx="4754880" cy="274320"/>
+            <a:ext cx="5669280" cy="274320"/>
           </a:xfrm>
           <a:prstGeom prst="rect">
             <a:avLst/>
@@ -3949,7 +4051,7 @@
               </a:defRPr>
             </a:pPr>
             <a:r>
-              <a:t>Recovery consistent across all severity levels and horizons</a:t>
+              <a:t>Isotonic and Platt perform comparably — recalibration itself matters, not the method</a:t>
             </a:r>
           </a:p>
         </p:txBody>
@@ -3970,8 +4072,8 @@
         </p:blipFill>
         <p:spPr>
           <a:xfrm>
-            <a:off x="5943600" y="1097280"/>
-            <a:ext cx="5303520" cy="4339244"/>
+            <a:off x="6400800" y="914400"/>
+            <a:ext cx="5029200" cy="4114800"/>
           </a:xfrm>
           <a:prstGeom prst="rect">
             <a:avLst/>
@@ -4009,7 +4111,7 @@
               </a:defRPr>
             </a:pPr>
             <a:r>
-              <a:t>10 / 11</a:t>
+              <a:t>10 / 14</a:t>
             </a:r>
           </a:p>
         </p:txBody>
@@ -4114,7 +4216,7 @@
               </a:defRPr>
             </a:pPr>
             <a:r>
-              <a:t>FRAMEWORK</a:t>
+              <a:t>ABLATION</a:t>
             </a:r>
           </a:p>
         </p:txBody>
@@ -4150,56 +4252,35 @@
               </a:defRPr>
             </a:pPr>
             <a:r>
-              <a:t>Three operating zones</a:t>
-            </a:r>
-          </a:p>
-        </p:txBody>
-      </p:sp>
-      <p:sp>
-        <p:nvSpPr>
-          <p:cNvPr id="5" name="Rounded Rectangle 4"/>
-          <p:cNvSpPr/>
-          <p:nvPr/>
-        </p:nvSpPr>
-        <p:spPr>
-          <a:xfrm>
-            <a:off x="731520" y="2286000"/>
-            <a:ext cx="3291840" cy="2743200"/>
-          </a:xfrm>
-          <a:prstGeom prst="roundRect">
-            <a:avLst/>
-          </a:prstGeom>
-          <a:solidFill>
-            <a:srgbClr val="F0FDF4"/>
-          </a:solidFill>
-          <a:ln w="12700">
-            <a:solidFill>
-              <a:srgbClr val="BBF7D0"/>
-            </a:solidFill>
-          </a:ln>
-        </p:spPr>
-        <p:style>
-          <a:lnRef idx="1">
-            <a:schemeClr val="accent1"/>
-          </a:lnRef>
-          <a:fillRef idx="3">
-            <a:schemeClr val="accent1"/>
-          </a:fillRef>
-          <a:effectRef idx="2">
-            <a:schemeClr val="accent1"/>
-          </a:effectRef>
-          <a:fontRef idx="minor">
-            <a:schemeClr val="lt1"/>
-          </a:fontRef>
-        </p:style>
-        <p:txBody>
-          <a:bodyPr rtlCol="0" anchor="ctr"/>
-          <a:lstStyle/>
-          <a:p>
-            <a:pPr algn="ctr"/>
-          </a:p>
-        </p:txBody>
-      </p:sp>
+              <a:t>Sample-size sweep: 5%–50%</a:t>
+            </a:r>
+          </a:p>
+        </p:txBody>
+      </p:sp>
+      <p:pic>
+        <p:nvPicPr>
+          <p:cNvPr id="5" name="Picture 4" descr="fig_sweep.png"/>
+          <p:cNvPicPr>
+            <a:picLocks noChangeAspect="1"/>
+          </p:cNvPicPr>
+          <p:nvPr/>
+        </p:nvPicPr>
+        <p:blipFill>
+          <a:blip r:embed="rId2"/>
+          <a:stretch>
+            <a:fillRect/>
+          </a:stretch>
+        </p:blipFill>
+        <p:spPr>
+          <a:xfrm>
+            <a:off x="914400" y="1280160"/>
+            <a:ext cx="7315200" cy="4876800"/>
+          </a:xfrm>
+          <a:prstGeom prst="rect">
+            <a:avLst/>
+          </a:prstGeom>
+        </p:spPr>
+      </p:pic>
       <p:sp>
         <p:nvSpPr>
           <p:cNvPr id="6" name="TextBox 5"/>
@@ -4208,8 +4289,8 @@
         </p:nvSpPr>
         <p:spPr>
           <a:xfrm>
-            <a:off x="731520" y="2560320"/>
-            <a:ext cx="3291840" cy="457200"/>
+            <a:off x="914400" y="5943600"/>
+            <a:ext cx="8229600" cy="457200"/>
           </a:xfrm>
           <a:prstGeom prst="rect">
             <a:avLst/>
@@ -4223,15 +4304,15 @@
           <a:lstStyle/>
           <a:p>
             <a:pPr algn="ctr">
-              <a:defRPr sz="3600" b="1">
-                <a:solidFill>
-                  <a:srgbClr val="16A34A"/>
-                </a:solidFill>
-                <a:latin typeface="Calibri"/>
-              </a:defRPr>
-            </a:pPr>
-            <a:r>
-              <a:t>● Safe</a:t>
+              <a:defRPr sz="1500" b="0">
+                <a:solidFill>
+                  <a:srgbClr val="64748B"/>
+                </a:solidFill>
+                <a:latin typeface="Calibri"/>
+              </a:defRPr>
+            </a:pPr>
+            <a:r>
+              <a:t>ECE decreases monotonically with sample fraction. The 10% fraction used throughout sits at the elbow — diminishing returns above 20%.</a:t>
             </a:r>
           </a:p>
         </p:txBody>
@@ -4244,8 +4325,8 @@
         </p:nvSpPr>
         <p:spPr>
           <a:xfrm>
-            <a:off x="731520" y="3108960"/>
-            <a:ext cx="3291840" cy="365760"/>
+            <a:off x="10241280" y="6400800"/>
+            <a:ext cx="1371600" cy="274320"/>
           </a:xfrm>
           <a:prstGeom prst="rect">
             <a:avLst/>
@@ -4258,428 +4339,6 @@
           </a:bodyPr>
           <a:lstStyle/>
           <a:p>
-            <a:pPr algn="ctr">
-              <a:defRPr sz="2200" b="1">
-                <a:solidFill>
-                  <a:srgbClr val="1E293B"/>
-                </a:solidFill>
-                <a:latin typeface="Calibri"/>
-              </a:defRPr>
-            </a:pPr>
-            <a:r>
-              <a:t>ECE &lt; 0.05</a:t>
-            </a:r>
-          </a:p>
-        </p:txBody>
-      </p:sp>
-      <p:sp>
-        <p:nvSpPr>
-          <p:cNvPr id="8" name="TextBox 7"/>
-          <p:cNvSpPr txBox="1"/>
-          <p:nvPr/>
-        </p:nvSpPr>
-        <p:spPr>
-          <a:xfrm>
-            <a:off x="914400" y="3474720"/>
-            <a:ext cx="2926080" cy="548640"/>
-          </a:xfrm>
-          <a:prstGeom prst="rect">
-            <a:avLst/>
-          </a:prstGeom>
-          <a:noFill/>
-        </p:spPr>
-        <p:txBody>
-          <a:bodyPr wrap="square">
-            <a:spAutoFit/>
-          </a:bodyPr>
-          <a:lstStyle/>
-          <a:p>
-            <a:pPr algn="ctr">
-              <a:defRPr sz="1400" b="0">
-                <a:solidFill>
-                  <a:srgbClr val="64748B"/>
-                </a:solidFill>
-                <a:latin typeface="Calibri"/>
-              </a:defRPr>
-            </a:pPr>
-            <a:r>
-              <a:t>Clean lab conditions only</a:t>
-            </a:r>
-          </a:p>
-        </p:txBody>
-      </p:sp>
-      <p:sp>
-        <p:nvSpPr>
-          <p:cNvPr id="9" name="Rounded Rectangle 8"/>
-          <p:cNvSpPr/>
-          <p:nvPr/>
-        </p:nvSpPr>
-        <p:spPr>
-          <a:xfrm>
-            <a:off x="4389120" y="2286000"/>
-            <a:ext cx="3291840" cy="2743200"/>
-          </a:xfrm>
-          <a:prstGeom prst="roundRect">
-            <a:avLst/>
-          </a:prstGeom>
-          <a:solidFill>
-            <a:srgbClr val="FFFBEB"/>
-          </a:solidFill>
-          <a:ln w="12700">
-            <a:solidFill>
-              <a:srgbClr val="FDE68A"/>
-            </a:solidFill>
-          </a:ln>
-        </p:spPr>
-        <p:style>
-          <a:lnRef idx="1">
-            <a:schemeClr val="accent1"/>
-          </a:lnRef>
-          <a:fillRef idx="3">
-            <a:schemeClr val="accent1"/>
-          </a:fillRef>
-          <a:effectRef idx="2">
-            <a:schemeClr val="accent1"/>
-          </a:effectRef>
-          <a:fontRef idx="minor">
-            <a:schemeClr val="lt1"/>
-          </a:fontRef>
-        </p:style>
-        <p:txBody>
-          <a:bodyPr rtlCol="0" anchor="ctr"/>
-          <a:lstStyle/>
-          <a:p>
-            <a:pPr algn="ctr"/>
-          </a:p>
-        </p:txBody>
-      </p:sp>
-      <p:sp>
-        <p:nvSpPr>
-          <p:cNvPr id="10" name="TextBox 9"/>
-          <p:cNvSpPr txBox="1"/>
-          <p:nvPr/>
-        </p:nvSpPr>
-        <p:spPr>
-          <a:xfrm>
-            <a:off x="4389120" y="2560320"/>
-            <a:ext cx="3291840" cy="457200"/>
-          </a:xfrm>
-          <a:prstGeom prst="rect">
-            <a:avLst/>
-          </a:prstGeom>
-          <a:noFill/>
-        </p:spPr>
-        <p:txBody>
-          <a:bodyPr wrap="square">
-            <a:spAutoFit/>
-          </a:bodyPr>
-          <a:lstStyle/>
-          <a:p>
-            <a:pPr algn="ctr">
-              <a:defRPr sz="3600" b="1">
-                <a:solidFill>
-                  <a:srgbClr val="D97706"/>
-                </a:solidFill>
-                <a:latin typeface="Calibri"/>
-              </a:defRPr>
-            </a:pPr>
-            <a:r>
-              <a:t>● Warning</a:t>
-            </a:r>
-          </a:p>
-        </p:txBody>
-      </p:sp>
-      <p:sp>
-        <p:nvSpPr>
-          <p:cNvPr id="11" name="TextBox 10"/>
-          <p:cNvSpPr txBox="1"/>
-          <p:nvPr/>
-        </p:nvSpPr>
-        <p:spPr>
-          <a:xfrm>
-            <a:off x="4389120" y="3108960"/>
-            <a:ext cx="3291840" cy="365760"/>
-          </a:xfrm>
-          <a:prstGeom prst="rect">
-            <a:avLst/>
-          </a:prstGeom>
-          <a:noFill/>
-        </p:spPr>
-        <p:txBody>
-          <a:bodyPr wrap="square">
-            <a:spAutoFit/>
-          </a:bodyPr>
-          <a:lstStyle/>
-          <a:p>
-            <a:pPr algn="ctr">
-              <a:defRPr sz="2200" b="1">
-                <a:solidFill>
-                  <a:srgbClr val="1E293B"/>
-                </a:solidFill>
-                <a:latin typeface="Calibri"/>
-              </a:defRPr>
-            </a:pPr>
-            <a:r>
-              <a:t>ECE 0.05–0.10</a:t>
-            </a:r>
-          </a:p>
-        </p:txBody>
-      </p:sp>
-      <p:sp>
-        <p:nvSpPr>
-          <p:cNvPr id="12" name="TextBox 11"/>
-          <p:cNvSpPr txBox="1"/>
-          <p:nvPr/>
-        </p:nvSpPr>
-        <p:spPr>
-          <a:xfrm>
-            <a:off x="4572000" y="3474720"/>
-            <a:ext cx="2926080" cy="548640"/>
-          </a:xfrm>
-          <a:prstGeom prst="rect">
-            <a:avLst/>
-          </a:prstGeom>
-          <a:noFill/>
-        </p:spPr>
-        <p:txBody>
-          <a:bodyPr wrap="square">
-            <a:spAutoFit/>
-          </a:bodyPr>
-          <a:lstStyle/>
-          <a:p>
-            <a:pPr algn="ctr">
-              <a:defRPr sz="1400" b="0">
-                <a:solidFill>
-                  <a:srgbClr val="64748B"/>
-                </a:solidFill>
-                <a:latin typeface="Calibri"/>
-              </a:defRPr>
-            </a:pPr>
-            <a:r>
-              <a:t>Recalibrated operation</a:t>
-            </a:r>
-            <a:br/>
-            <a:r>
-              <a:t>10% operational sample</a:t>
-            </a:r>
-          </a:p>
-        </p:txBody>
-      </p:sp>
-      <p:sp>
-        <p:nvSpPr>
-          <p:cNvPr id="13" name="Rounded Rectangle 12"/>
-          <p:cNvSpPr/>
-          <p:nvPr/>
-        </p:nvSpPr>
-        <p:spPr>
-          <a:xfrm>
-            <a:off x="8046720" y="2286000"/>
-            <a:ext cx="3291840" cy="2743200"/>
-          </a:xfrm>
-          <a:prstGeom prst="roundRect">
-            <a:avLst/>
-          </a:prstGeom>
-          <a:solidFill>
-            <a:srgbClr val="FEF2F2"/>
-          </a:solidFill>
-          <a:ln w="12700">
-            <a:solidFill>
-              <a:srgbClr val="FECACA"/>
-            </a:solidFill>
-          </a:ln>
-        </p:spPr>
-        <p:style>
-          <a:lnRef idx="1">
-            <a:schemeClr val="accent1"/>
-          </a:lnRef>
-          <a:fillRef idx="3">
-            <a:schemeClr val="accent1"/>
-          </a:fillRef>
-          <a:effectRef idx="2">
-            <a:schemeClr val="accent1"/>
-          </a:effectRef>
-          <a:fontRef idx="minor">
-            <a:schemeClr val="lt1"/>
-          </a:fontRef>
-        </p:style>
-        <p:txBody>
-          <a:bodyPr rtlCol="0" anchor="ctr"/>
-          <a:lstStyle/>
-          <a:p>
-            <a:pPr algn="ctr"/>
-          </a:p>
-        </p:txBody>
-      </p:sp>
-      <p:sp>
-        <p:nvSpPr>
-          <p:cNvPr id="14" name="TextBox 13"/>
-          <p:cNvSpPr txBox="1"/>
-          <p:nvPr/>
-        </p:nvSpPr>
-        <p:spPr>
-          <a:xfrm>
-            <a:off x="8046720" y="2560320"/>
-            <a:ext cx="3291840" cy="457200"/>
-          </a:xfrm>
-          <a:prstGeom prst="rect">
-            <a:avLst/>
-          </a:prstGeom>
-          <a:noFill/>
-        </p:spPr>
-        <p:txBody>
-          <a:bodyPr wrap="square">
-            <a:spAutoFit/>
-          </a:bodyPr>
-          <a:lstStyle/>
-          <a:p>
-            <a:pPr algn="ctr">
-              <a:defRPr sz="3600" b="1">
-                <a:solidFill>
-                  <a:srgbClr val="DC2626"/>
-                </a:solidFill>
-                <a:latin typeface="Calibri"/>
-              </a:defRPr>
-            </a:pPr>
-            <a:r>
-              <a:t>● Unsafe</a:t>
-            </a:r>
-          </a:p>
-        </p:txBody>
-      </p:sp>
-      <p:sp>
-        <p:nvSpPr>
-          <p:cNvPr id="15" name="TextBox 14"/>
-          <p:cNvSpPr txBox="1"/>
-          <p:nvPr/>
-        </p:nvSpPr>
-        <p:spPr>
-          <a:xfrm>
-            <a:off x="8046720" y="3108960"/>
-            <a:ext cx="3291840" cy="365760"/>
-          </a:xfrm>
-          <a:prstGeom prst="rect">
-            <a:avLst/>
-          </a:prstGeom>
-          <a:noFill/>
-        </p:spPr>
-        <p:txBody>
-          <a:bodyPr wrap="square">
-            <a:spAutoFit/>
-          </a:bodyPr>
-          <a:lstStyle/>
-          <a:p>
-            <a:pPr algn="ctr">
-              <a:defRPr sz="2200" b="1">
-                <a:solidFill>
-                  <a:srgbClr val="1E293B"/>
-                </a:solidFill>
-                <a:latin typeface="Calibri"/>
-              </a:defRPr>
-            </a:pPr>
-            <a:r>
-              <a:t>ECE &gt; 0.10</a:t>
-            </a:r>
-          </a:p>
-        </p:txBody>
-      </p:sp>
-      <p:sp>
-        <p:nvSpPr>
-          <p:cNvPr id="16" name="TextBox 15"/>
-          <p:cNvSpPr txBox="1"/>
-          <p:nvPr/>
-        </p:nvSpPr>
-        <p:spPr>
-          <a:xfrm>
-            <a:off x="8229600" y="3474720"/>
-            <a:ext cx="2926080" cy="548640"/>
-          </a:xfrm>
-          <a:prstGeom prst="rect">
-            <a:avLst/>
-          </a:prstGeom>
-          <a:noFill/>
-        </p:spPr>
-        <p:txBody>
-          <a:bodyPr wrap="square">
-            <a:spAutoFit/>
-          </a:bodyPr>
-          <a:lstStyle/>
-          <a:p>
-            <a:pPr algn="ctr">
-              <a:defRPr sz="1400" b="0">
-                <a:solidFill>
-                  <a:srgbClr val="64748B"/>
-                </a:solidFill>
-                <a:latin typeface="Calibri"/>
-              </a:defRPr>
-            </a:pPr>
-            <a:r>
-              <a:t>Direct deployment under</a:t>
-            </a:r>
-            <a:br/>
-            <a:r>
-              <a:t>any partial cycling (ECE &gt; 0.27)</a:t>
-            </a:r>
-          </a:p>
-        </p:txBody>
-      </p:sp>
-      <p:sp>
-        <p:nvSpPr>
-          <p:cNvPr id="17" name="TextBox 16"/>
-          <p:cNvSpPr txBox="1"/>
-          <p:nvPr/>
-        </p:nvSpPr>
-        <p:spPr>
-          <a:xfrm>
-            <a:off x="731520" y="5303520"/>
-            <a:ext cx="10058400" cy="365760"/>
-          </a:xfrm>
-          <a:prstGeom prst="rect">
-            <a:avLst/>
-          </a:prstGeom>
-          <a:noFill/>
-        </p:spPr>
-        <p:txBody>
-          <a:bodyPr wrap="square">
-            <a:spAutoFit/>
-          </a:bodyPr>
-          <a:lstStyle/>
-          <a:p>
-            <a:pPr algn="ctr">
-              <a:defRPr sz="1600" b="0">
-                <a:solidFill>
-                  <a:srgbClr val="64748B"/>
-                </a:solidFill>
-                <a:latin typeface="Calibri"/>
-              </a:defRPr>
-            </a:pPr>
-            <a:r>
-              <a:t>Direct deployment under partial cycling pushes ECE &gt; 0.27 — firmly in the unsafe zone</a:t>
-            </a:r>
-          </a:p>
-        </p:txBody>
-      </p:sp>
-      <p:sp>
-        <p:nvSpPr>
-          <p:cNvPr id="18" name="TextBox 17"/>
-          <p:cNvSpPr txBox="1"/>
-          <p:nvPr/>
-        </p:nvSpPr>
-        <p:spPr>
-          <a:xfrm>
-            <a:off x="10241280" y="6400800"/>
-            <a:ext cx="1371600" cy="274320"/>
-          </a:xfrm>
-          <a:prstGeom prst="rect">
-            <a:avLst/>
-          </a:prstGeom>
-          <a:noFill/>
-        </p:spPr>
-        <p:txBody>
-          <a:bodyPr wrap="square">
-            <a:spAutoFit/>
-          </a:bodyPr>
-          <a:lstStyle/>
-          <a:p>
             <a:pPr algn="r">
               <a:defRPr sz="1000" b="0">
                 <a:solidFill>
@@ -4689,7 +4348,7 @@
               </a:defRPr>
             </a:pPr>
             <a:r>
-              <a:t>11 / 11</a:t>
+              <a:t>11 / 14</a:t>
             </a:r>
           </a:p>
         </p:txBody>
@@ -4794,7 +4453,7 @@
               </a:defRPr>
             </a:pPr>
             <a:r>
-              <a:t>ACTION</a:t>
+              <a:t>FRAMEWORK</a:t>
             </a:r>
           </a:p>
         </p:txBody>
@@ -4830,151 +4489,31 @@
               </a:defRPr>
             </a:pPr>
             <a:r>
-              <a:t>Practical deployment path</a:t>
-            </a:r>
-          </a:p>
-        </p:txBody>
-      </p:sp>
-      <p:sp>
-        <p:nvSpPr>
-          <p:cNvPr id="5" name="TextBox 4"/>
-          <p:cNvSpPr txBox="1"/>
-          <p:nvPr/>
-        </p:nvSpPr>
-        <p:spPr>
-          <a:xfrm>
-            <a:off x="731520" y="1463040"/>
-            <a:ext cx="6858000" cy="2743200"/>
-          </a:xfrm>
-          <a:prstGeom prst="rect">
-            <a:avLst/>
-          </a:prstGeom>
-          <a:noFill/>
-        </p:spPr>
-        <p:txBody>
-          <a:bodyPr wrap="square">
-            <a:spAutoFit/>
-          </a:bodyPr>
-          <a:lstStyle/>
-          <a:p>
-            <a:pPr algn="l">
-              <a:defRPr sz="2000" b="0">
-                <a:solidFill>
-                  <a:srgbClr val="1E293B"/>
-                </a:solidFill>
-                <a:latin typeface="Calibri"/>
-              </a:defRPr>
-            </a:pPr>
-            <a:r>
-              <a:t>1. Deploy the frozen XGBoost model as-is</a:t>
-            </a:r>
-          </a:p>
-          <a:p>
-            <a:pPr algn="l">
-              <a:spcBef>
-                <a:spcPts val="1000"/>
-              </a:spcBef>
-              <a:defRPr sz="2000" b="0">
-                <a:solidFill>
-                  <a:srgbClr val="1E293B"/>
-                </a:solidFill>
-                <a:latin typeface="Calibri"/>
-              </a:defRPr>
-            </a:pPr>
-            <a:r>
-              <a:t>2. Collect 50–100 operational cycles from normal BESS operation</a:t>
-            </a:r>
-          </a:p>
-          <a:p>
-            <a:pPr algn="l">
-              <a:spcBef>
-                <a:spcPts val="1000"/>
-              </a:spcBef>
-              <a:defRPr sz="2000" b="0">
-                <a:solidFill>
-                  <a:srgbClr val="1E293B"/>
-                </a:solidFill>
-                <a:latin typeface="Calibri"/>
-              </a:defRPr>
-            </a:pPr>
-            <a:r>
-              <a:t>3. Fit a new isotonic regression on these cycles</a:t>
-            </a:r>
-          </a:p>
-          <a:p>
-            <a:pPr algn="l">
-              <a:spcBef>
-                <a:spcPts val="1000"/>
-              </a:spcBef>
-              <a:defRPr sz="2000" b="0">
-                <a:solidFill>
-                  <a:srgbClr val="1E293B"/>
-                </a:solidFill>
-                <a:latin typeface="Calibri"/>
-              </a:defRPr>
-            </a:pPr>
-            <a:r>
-              <a:t>4. Deploy the recalibrated model — no base classifier retraining needed</a:t>
-            </a:r>
-          </a:p>
-        </p:txBody>
-      </p:sp>
-      <p:sp>
-        <p:nvSpPr>
-          <p:cNvPr id="6" name="TextBox 5"/>
-          <p:cNvSpPr txBox="1"/>
-          <p:nvPr/>
-        </p:nvSpPr>
-        <p:spPr>
-          <a:xfrm>
-            <a:off x="731520" y="4389120"/>
-            <a:ext cx="6858000" cy="365760"/>
-          </a:xfrm>
-          <a:prstGeom prst="rect">
-            <a:avLst/>
-          </a:prstGeom>
-          <a:noFill/>
-        </p:spPr>
-        <p:txBody>
-          <a:bodyPr wrap="square">
-            <a:spAutoFit/>
-          </a:bodyPr>
-          <a:lstStyle/>
-          <a:p>
-            <a:pPr algn="l">
-              <a:defRPr sz="1400" b="0">
-                <a:solidFill>
-                  <a:srgbClr val="64748B"/>
-                </a:solidFill>
-                <a:latin typeface="Calibri"/>
-              </a:defRPr>
-            </a:pPr>
-            <a:r>
-              <a:t>No original training data required · No additional feature engineering</a:t>
-            </a:r>
-          </a:p>
-        </p:txBody>
-      </p:sp>
-      <p:sp>
-        <p:nvSpPr>
-          <p:cNvPr id="7" name="Rounded Rectangle 6"/>
+              <a:t>Three operating zones</a:t>
+            </a:r>
+          </a:p>
+        </p:txBody>
+      </p:sp>
+      <p:sp>
+        <p:nvSpPr>
+          <p:cNvPr id="5" name="Rounded Rectangle 4"/>
           <p:cNvSpPr/>
           <p:nvPr/>
         </p:nvSpPr>
         <p:spPr>
           <a:xfrm>
-            <a:off x="8229600" y="1828800"/>
-            <a:ext cx="3200400" cy="1828800"/>
+            <a:off x="731520" y="2286000"/>
+            <a:ext cx="3291840" cy="2743200"/>
           </a:xfrm>
           <a:prstGeom prst="roundRect">
             <a:avLst/>
           </a:prstGeom>
           <a:solidFill>
-            <a:srgbClr val="FFFFFF"/>
+            <a:srgbClr val="F0FDF4"/>
           </a:solidFill>
           <a:ln w="12700">
             <a:solidFill>
-              <a:srgbClr val="E2E8F0"/>
+              <a:srgbClr val="BBF7D0"/>
             </a:solidFill>
           </a:ln>
         </p:spPr>
@@ -5002,14 +4541,14 @@
       </p:sp>
       <p:sp>
         <p:nvSpPr>
-          <p:cNvPr id="8" name="TextBox 7"/>
+          <p:cNvPr id="6" name="TextBox 5"/>
           <p:cNvSpPr txBox="1"/>
           <p:nvPr/>
         </p:nvSpPr>
         <p:spPr>
           <a:xfrm>
-            <a:off x="8412480" y="2011680"/>
-            <a:ext cx="2834640" cy="548640"/>
+            <a:off x="731520" y="2560320"/>
+            <a:ext cx="3291840" cy="457200"/>
           </a:xfrm>
           <a:prstGeom prst="rect">
             <a:avLst/>
@@ -5023,7 +4562,7 @@
           <a:lstStyle/>
           <a:p>
             <a:pPr algn="ctr">
-              <a:defRPr sz="4800" b="1">
+              <a:defRPr sz="3600" b="1">
                 <a:solidFill>
                   <a:srgbClr val="16A34A"/>
                 </a:solidFill>
@@ -5031,21 +4570,21 @@
               </a:defRPr>
             </a:pPr>
             <a:r>
-              <a:t>10%</a:t>
-            </a:r>
-          </a:p>
-        </p:txBody>
-      </p:sp>
-      <p:sp>
-        <p:nvSpPr>
-          <p:cNvPr id="9" name="TextBox 8"/>
+              <a:t>● Safe</a:t>
+            </a:r>
+          </a:p>
+        </p:txBody>
+      </p:sp>
+      <p:sp>
+        <p:nvSpPr>
+          <p:cNvPr id="7" name="TextBox 6"/>
           <p:cNvSpPr txBox="1"/>
           <p:nvPr/>
         </p:nvSpPr>
         <p:spPr>
           <a:xfrm>
-            <a:off x="8412480" y="2560320"/>
-            <a:ext cx="2834640" cy="365760"/>
+            <a:off x="731520" y="3108960"/>
+            <a:ext cx="3291840" cy="365760"/>
           </a:xfrm>
           <a:prstGeom prst="rect">
             <a:avLst/>
@@ -5059,29 +4598,29 @@
           <a:lstStyle/>
           <a:p>
             <a:pPr algn="ctr">
-              <a:defRPr sz="1600" b="0">
-                <a:solidFill>
-                  <a:srgbClr val="64748B"/>
-                </a:solidFill>
-                <a:latin typeface="Calibri"/>
-              </a:defRPr>
-            </a:pPr>
-            <a:r>
-              <a:t>operational sample suffices</a:t>
-            </a:r>
-          </a:p>
-        </p:txBody>
-      </p:sp>
-      <p:sp>
-        <p:nvSpPr>
-          <p:cNvPr id="10" name="TextBox 9"/>
+              <a:defRPr sz="2200" b="1">
+                <a:solidFill>
+                  <a:srgbClr val="1E293B"/>
+                </a:solidFill>
+                <a:latin typeface="Calibri"/>
+              </a:defRPr>
+            </a:pPr>
+            <a:r>
+              <a:t>ECE &lt; 0.05</a:t>
+            </a:r>
+          </a:p>
+        </p:txBody>
+      </p:sp>
+      <p:sp>
+        <p:nvSpPr>
+          <p:cNvPr id="8" name="TextBox 7"/>
           <p:cNvSpPr txBox="1"/>
           <p:nvPr/>
         </p:nvSpPr>
         <p:spPr>
           <a:xfrm>
-            <a:off x="10241280" y="6400800"/>
-            <a:ext cx="1371600" cy="274320"/>
+            <a:off x="914400" y="3474720"/>
+            <a:ext cx="2926080" cy="548640"/>
           </a:xfrm>
           <a:prstGeom prst="rect">
             <a:avLst/>
@@ -5094,6 +4633,392 @@
           </a:bodyPr>
           <a:lstStyle/>
           <a:p>
+            <a:pPr algn="ctr">
+              <a:defRPr sz="1400" b="0">
+                <a:solidFill>
+                  <a:srgbClr val="64748B"/>
+                </a:solidFill>
+                <a:latin typeface="Calibri"/>
+              </a:defRPr>
+            </a:pPr>
+            <a:r>
+              <a:t>Clean lab conditions only</a:t>
+            </a:r>
+          </a:p>
+        </p:txBody>
+      </p:sp>
+      <p:sp>
+        <p:nvSpPr>
+          <p:cNvPr id="9" name="Rounded Rectangle 8"/>
+          <p:cNvSpPr/>
+          <p:nvPr/>
+        </p:nvSpPr>
+        <p:spPr>
+          <a:xfrm>
+            <a:off x="4389120" y="2286000"/>
+            <a:ext cx="3291840" cy="2743200"/>
+          </a:xfrm>
+          <a:prstGeom prst="roundRect">
+            <a:avLst/>
+          </a:prstGeom>
+          <a:solidFill>
+            <a:srgbClr val="FFFBEB"/>
+          </a:solidFill>
+          <a:ln w="12700">
+            <a:solidFill>
+              <a:srgbClr val="FDE68A"/>
+            </a:solidFill>
+          </a:ln>
+        </p:spPr>
+        <p:style>
+          <a:lnRef idx="1">
+            <a:schemeClr val="accent1"/>
+          </a:lnRef>
+          <a:fillRef idx="3">
+            <a:schemeClr val="accent1"/>
+          </a:fillRef>
+          <a:effectRef idx="2">
+            <a:schemeClr val="accent1"/>
+          </a:effectRef>
+          <a:fontRef idx="minor">
+            <a:schemeClr val="lt1"/>
+          </a:fontRef>
+        </p:style>
+        <p:txBody>
+          <a:bodyPr rtlCol="0" anchor="ctr"/>
+          <a:lstStyle/>
+          <a:p>
+            <a:pPr algn="ctr"/>
+          </a:p>
+        </p:txBody>
+      </p:sp>
+      <p:sp>
+        <p:nvSpPr>
+          <p:cNvPr id="10" name="TextBox 9"/>
+          <p:cNvSpPr txBox="1"/>
+          <p:nvPr/>
+        </p:nvSpPr>
+        <p:spPr>
+          <a:xfrm>
+            <a:off x="4389120" y="2560320"/>
+            <a:ext cx="3291840" cy="457200"/>
+          </a:xfrm>
+          <a:prstGeom prst="rect">
+            <a:avLst/>
+          </a:prstGeom>
+          <a:noFill/>
+        </p:spPr>
+        <p:txBody>
+          <a:bodyPr wrap="square">
+            <a:spAutoFit/>
+          </a:bodyPr>
+          <a:lstStyle/>
+          <a:p>
+            <a:pPr algn="ctr">
+              <a:defRPr sz="3600" b="1">
+                <a:solidFill>
+                  <a:srgbClr val="D97706"/>
+                </a:solidFill>
+                <a:latin typeface="Calibri"/>
+              </a:defRPr>
+            </a:pPr>
+            <a:r>
+              <a:t>● Warning</a:t>
+            </a:r>
+          </a:p>
+        </p:txBody>
+      </p:sp>
+      <p:sp>
+        <p:nvSpPr>
+          <p:cNvPr id="11" name="TextBox 10"/>
+          <p:cNvSpPr txBox="1"/>
+          <p:nvPr/>
+        </p:nvSpPr>
+        <p:spPr>
+          <a:xfrm>
+            <a:off x="4389120" y="3108960"/>
+            <a:ext cx="3291840" cy="365760"/>
+          </a:xfrm>
+          <a:prstGeom prst="rect">
+            <a:avLst/>
+          </a:prstGeom>
+          <a:noFill/>
+        </p:spPr>
+        <p:txBody>
+          <a:bodyPr wrap="square">
+            <a:spAutoFit/>
+          </a:bodyPr>
+          <a:lstStyle/>
+          <a:p>
+            <a:pPr algn="ctr">
+              <a:defRPr sz="2200" b="1">
+                <a:solidFill>
+                  <a:srgbClr val="1E293B"/>
+                </a:solidFill>
+                <a:latin typeface="Calibri"/>
+              </a:defRPr>
+            </a:pPr>
+            <a:r>
+              <a:t>ECE 0.05–0.10</a:t>
+            </a:r>
+          </a:p>
+        </p:txBody>
+      </p:sp>
+      <p:sp>
+        <p:nvSpPr>
+          <p:cNvPr id="12" name="TextBox 11"/>
+          <p:cNvSpPr txBox="1"/>
+          <p:nvPr/>
+        </p:nvSpPr>
+        <p:spPr>
+          <a:xfrm>
+            <a:off x="4572000" y="3474720"/>
+            <a:ext cx="2926080" cy="548640"/>
+          </a:xfrm>
+          <a:prstGeom prst="rect">
+            <a:avLst/>
+          </a:prstGeom>
+          <a:noFill/>
+        </p:spPr>
+        <p:txBody>
+          <a:bodyPr wrap="square">
+            <a:spAutoFit/>
+          </a:bodyPr>
+          <a:lstStyle/>
+          <a:p>
+            <a:pPr algn="ctr">
+              <a:defRPr sz="1400" b="0">
+                <a:solidFill>
+                  <a:srgbClr val="64748B"/>
+                </a:solidFill>
+                <a:latin typeface="Calibri"/>
+              </a:defRPr>
+            </a:pPr>
+            <a:r>
+              <a:t>Recalibrated operation</a:t>
+            </a:r>
+            <a:br/>
+            <a:r>
+              <a:t>10% operational sample</a:t>
+            </a:r>
+          </a:p>
+        </p:txBody>
+      </p:sp>
+      <p:sp>
+        <p:nvSpPr>
+          <p:cNvPr id="13" name="Rounded Rectangle 12"/>
+          <p:cNvSpPr/>
+          <p:nvPr/>
+        </p:nvSpPr>
+        <p:spPr>
+          <a:xfrm>
+            <a:off x="8046720" y="2286000"/>
+            <a:ext cx="3291840" cy="2743200"/>
+          </a:xfrm>
+          <a:prstGeom prst="roundRect">
+            <a:avLst/>
+          </a:prstGeom>
+          <a:solidFill>
+            <a:srgbClr val="FEF2F2"/>
+          </a:solidFill>
+          <a:ln w="12700">
+            <a:solidFill>
+              <a:srgbClr val="FECACA"/>
+            </a:solidFill>
+          </a:ln>
+        </p:spPr>
+        <p:style>
+          <a:lnRef idx="1">
+            <a:schemeClr val="accent1"/>
+          </a:lnRef>
+          <a:fillRef idx="3">
+            <a:schemeClr val="accent1"/>
+          </a:fillRef>
+          <a:effectRef idx="2">
+            <a:schemeClr val="accent1"/>
+          </a:effectRef>
+          <a:fontRef idx="minor">
+            <a:schemeClr val="lt1"/>
+          </a:fontRef>
+        </p:style>
+        <p:txBody>
+          <a:bodyPr rtlCol="0" anchor="ctr"/>
+          <a:lstStyle/>
+          <a:p>
+            <a:pPr algn="ctr"/>
+          </a:p>
+        </p:txBody>
+      </p:sp>
+      <p:sp>
+        <p:nvSpPr>
+          <p:cNvPr id="14" name="TextBox 13"/>
+          <p:cNvSpPr txBox="1"/>
+          <p:nvPr/>
+        </p:nvSpPr>
+        <p:spPr>
+          <a:xfrm>
+            <a:off x="8046720" y="2560320"/>
+            <a:ext cx="3291840" cy="457200"/>
+          </a:xfrm>
+          <a:prstGeom prst="rect">
+            <a:avLst/>
+          </a:prstGeom>
+          <a:noFill/>
+        </p:spPr>
+        <p:txBody>
+          <a:bodyPr wrap="square">
+            <a:spAutoFit/>
+          </a:bodyPr>
+          <a:lstStyle/>
+          <a:p>
+            <a:pPr algn="ctr">
+              <a:defRPr sz="3600" b="1">
+                <a:solidFill>
+                  <a:srgbClr val="DC2626"/>
+                </a:solidFill>
+                <a:latin typeface="Calibri"/>
+              </a:defRPr>
+            </a:pPr>
+            <a:r>
+              <a:t>● Unsafe</a:t>
+            </a:r>
+          </a:p>
+        </p:txBody>
+      </p:sp>
+      <p:sp>
+        <p:nvSpPr>
+          <p:cNvPr id="15" name="TextBox 14"/>
+          <p:cNvSpPr txBox="1"/>
+          <p:nvPr/>
+        </p:nvSpPr>
+        <p:spPr>
+          <a:xfrm>
+            <a:off x="8046720" y="3108960"/>
+            <a:ext cx="3291840" cy="365760"/>
+          </a:xfrm>
+          <a:prstGeom prst="rect">
+            <a:avLst/>
+          </a:prstGeom>
+          <a:noFill/>
+        </p:spPr>
+        <p:txBody>
+          <a:bodyPr wrap="square">
+            <a:spAutoFit/>
+          </a:bodyPr>
+          <a:lstStyle/>
+          <a:p>
+            <a:pPr algn="ctr">
+              <a:defRPr sz="2200" b="1">
+                <a:solidFill>
+                  <a:srgbClr val="1E293B"/>
+                </a:solidFill>
+                <a:latin typeface="Calibri"/>
+              </a:defRPr>
+            </a:pPr>
+            <a:r>
+              <a:t>ECE &gt; 0.10</a:t>
+            </a:r>
+          </a:p>
+        </p:txBody>
+      </p:sp>
+      <p:sp>
+        <p:nvSpPr>
+          <p:cNvPr id="16" name="TextBox 15"/>
+          <p:cNvSpPr txBox="1"/>
+          <p:nvPr/>
+        </p:nvSpPr>
+        <p:spPr>
+          <a:xfrm>
+            <a:off x="8229600" y="3474720"/>
+            <a:ext cx="2926080" cy="548640"/>
+          </a:xfrm>
+          <a:prstGeom prst="rect">
+            <a:avLst/>
+          </a:prstGeom>
+          <a:noFill/>
+        </p:spPr>
+        <p:txBody>
+          <a:bodyPr wrap="square">
+            <a:spAutoFit/>
+          </a:bodyPr>
+          <a:lstStyle/>
+          <a:p>
+            <a:pPr algn="ctr">
+              <a:defRPr sz="1400" b="0">
+                <a:solidFill>
+                  <a:srgbClr val="64748B"/>
+                </a:solidFill>
+                <a:latin typeface="Calibri"/>
+              </a:defRPr>
+            </a:pPr>
+            <a:r>
+              <a:t>Direct deployment under</a:t>
+            </a:r>
+            <a:br/>
+            <a:r>
+              <a:t>any partial cycling (ECE &gt; 0.27)</a:t>
+            </a:r>
+          </a:p>
+        </p:txBody>
+      </p:sp>
+      <p:sp>
+        <p:nvSpPr>
+          <p:cNvPr id="17" name="TextBox 16"/>
+          <p:cNvSpPr txBox="1"/>
+          <p:nvPr/>
+        </p:nvSpPr>
+        <p:spPr>
+          <a:xfrm>
+            <a:off x="731520" y="5303520"/>
+            <a:ext cx="10058400" cy="365760"/>
+          </a:xfrm>
+          <a:prstGeom prst="rect">
+            <a:avLst/>
+          </a:prstGeom>
+          <a:noFill/>
+        </p:spPr>
+        <p:txBody>
+          <a:bodyPr wrap="square">
+            <a:spAutoFit/>
+          </a:bodyPr>
+          <a:lstStyle/>
+          <a:p>
+            <a:pPr algn="ctr">
+              <a:defRPr sz="1600" b="0">
+                <a:solidFill>
+                  <a:srgbClr val="64748B"/>
+                </a:solidFill>
+                <a:latin typeface="Calibri"/>
+              </a:defRPr>
+            </a:pPr>
+            <a:r>
+              <a:t>Direct deployment under partial cycling pushes ECE &gt; 0.27 — firmly in the unsafe zone</a:t>
+            </a:r>
+          </a:p>
+        </p:txBody>
+      </p:sp>
+      <p:sp>
+        <p:nvSpPr>
+          <p:cNvPr id="18" name="TextBox 17"/>
+          <p:cNvSpPr txBox="1"/>
+          <p:nvPr/>
+        </p:nvSpPr>
+        <p:spPr>
+          <a:xfrm>
+            <a:off x="10241280" y="6400800"/>
+            <a:ext cx="1371600" cy="274320"/>
+          </a:xfrm>
+          <a:prstGeom prst="rect">
+            <a:avLst/>
+          </a:prstGeom>
+          <a:noFill/>
+        </p:spPr>
+        <p:txBody>
+          <a:bodyPr wrap="square">
+            <a:spAutoFit/>
+          </a:bodyPr>
+          <a:lstStyle/>
+          <a:p>
             <a:pPr algn="r">
               <a:defRPr sz="1000" b="0">
                 <a:solidFill>
@@ -5103,7 +5028,7 @@
               </a:defRPr>
             </a:pPr>
             <a:r>
-              <a:t>12 / 11</a:t>
+              <a:t>12 / 14</a:t>
             </a:r>
           </a:p>
         </p:txBody>
@@ -5117,6 +5042,420 @@
 </file>
 
 <file path=ppt/slides/slide13.xml><?xml version="1.0" encoding="utf-8"?>
+<p:sld xmlns:a="http://schemas.openxmlformats.org/drawingml/2006/main" xmlns:p="http://schemas.openxmlformats.org/presentationml/2006/main" xmlns:r="http://schemas.openxmlformats.org/officeDocument/2006/relationships">
+  <p:cSld>
+    <p:bg>
+      <p:bgPr>
+        <a:solidFill>
+          <a:srgbClr val="F8FAFC"/>
+        </a:solidFill>
+        <a:effectLst/>
+      </p:bgPr>
+    </p:bg>
+    <p:spTree>
+      <p:nvGrpSpPr>
+        <p:cNvPr id="1" name=""/>
+        <p:cNvGrpSpPr/>
+        <p:nvPr/>
+      </p:nvGrpSpPr>
+      <p:grpSpPr/>
+      <p:sp>
+        <p:nvSpPr>
+          <p:cNvPr id="2" name="Rectangle 1"/>
+          <p:cNvSpPr/>
+          <p:nvPr/>
+        </p:nvSpPr>
+        <p:spPr>
+          <a:xfrm>
+            <a:off x="0" y="6818000"/>
+            <a:ext cx="12192000" cy="40000"/>
+          </a:xfrm>
+          <a:prstGeom prst="rect">
+            <a:avLst/>
+          </a:prstGeom>
+          <a:solidFill>
+            <a:srgbClr val="F59E0B"/>
+          </a:solidFill>
+          <a:ln>
+            <a:noFill/>
+          </a:ln>
+        </p:spPr>
+        <p:style>
+          <a:lnRef idx="1">
+            <a:schemeClr val="accent1"/>
+          </a:lnRef>
+          <a:fillRef idx="3">
+            <a:schemeClr val="accent1"/>
+          </a:fillRef>
+          <a:effectRef idx="2">
+            <a:schemeClr val="accent1"/>
+          </a:effectRef>
+          <a:fontRef idx="minor">
+            <a:schemeClr val="lt1"/>
+          </a:fontRef>
+        </p:style>
+        <p:txBody>
+          <a:bodyPr rtlCol="0" anchor="ctr"/>
+          <a:lstStyle/>
+          <a:p>
+            <a:pPr algn="ctr"/>
+          </a:p>
+        </p:txBody>
+      </p:sp>
+      <p:sp>
+        <p:nvSpPr>
+          <p:cNvPr id="3" name="TextBox 2"/>
+          <p:cNvSpPr txBox="1"/>
+          <p:nvPr/>
+        </p:nvSpPr>
+        <p:spPr>
+          <a:xfrm>
+            <a:off x="731520" y="365760"/>
+            <a:ext cx="3657600" cy="274320"/>
+          </a:xfrm>
+          <a:prstGeom prst="rect">
+            <a:avLst/>
+          </a:prstGeom>
+          <a:noFill/>
+        </p:spPr>
+        <p:txBody>
+          <a:bodyPr wrap="square">
+            <a:spAutoFit/>
+          </a:bodyPr>
+          <a:lstStyle/>
+          <a:p>
+            <a:pPr algn="l">
+              <a:defRPr sz="1100" b="1">
+                <a:solidFill>
+                  <a:srgbClr val="F59E0B"/>
+                </a:solidFill>
+                <a:latin typeface="Calibri"/>
+              </a:defRPr>
+            </a:pPr>
+            <a:r>
+              <a:t>ACTION</a:t>
+            </a:r>
+          </a:p>
+        </p:txBody>
+      </p:sp>
+      <p:sp>
+        <p:nvSpPr>
+          <p:cNvPr id="4" name="TextBox 3"/>
+          <p:cNvSpPr txBox="1"/>
+          <p:nvPr/>
+        </p:nvSpPr>
+        <p:spPr>
+          <a:xfrm>
+            <a:off x="731520" y="640080"/>
+            <a:ext cx="9144000" cy="548640"/>
+          </a:xfrm>
+          <a:prstGeom prst="rect">
+            <a:avLst/>
+          </a:prstGeom>
+          <a:noFill/>
+        </p:spPr>
+        <p:txBody>
+          <a:bodyPr wrap="square">
+            <a:spAutoFit/>
+          </a:bodyPr>
+          <a:lstStyle/>
+          <a:p>
+            <a:pPr algn="l">
+              <a:defRPr sz="3600" b="1">
+                <a:solidFill>
+                  <a:srgbClr val="0F172A"/>
+                </a:solidFill>
+                <a:latin typeface="Calibri"/>
+              </a:defRPr>
+            </a:pPr>
+            <a:r>
+              <a:t>Practical deployment path</a:t>
+            </a:r>
+          </a:p>
+        </p:txBody>
+      </p:sp>
+      <p:sp>
+        <p:nvSpPr>
+          <p:cNvPr id="5" name="TextBox 4"/>
+          <p:cNvSpPr txBox="1"/>
+          <p:nvPr/>
+        </p:nvSpPr>
+        <p:spPr>
+          <a:xfrm>
+            <a:off x="731520" y="1463040"/>
+            <a:ext cx="6858000" cy="2743200"/>
+          </a:xfrm>
+          <a:prstGeom prst="rect">
+            <a:avLst/>
+          </a:prstGeom>
+          <a:noFill/>
+        </p:spPr>
+        <p:txBody>
+          <a:bodyPr wrap="square">
+            <a:spAutoFit/>
+          </a:bodyPr>
+          <a:lstStyle/>
+          <a:p>
+            <a:pPr algn="l">
+              <a:defRPr sz="2000" b="0">
+                <a:solidFill>
+                  <a:srgbClr val="1E293B"/>
+                </a:solidFill>
+                <a:latin typeface="Calibri"/>
+              </a:defRPr>
+            </a:pPr>
+            <a:r>
+              <a:t>1. Deploy the frozen XGBoost model as-is</a:t>
+            </a:r>
+          </a:p>
+          <a:p>
+            <a:pPr algn="l">
+              <a:spcBef>
+                <a:spcPts val="1000"/>
+              </a:spcBef>
+              <a:defRPr sz="2000" b="0">
+                <a:solidFill>
+                  <a:srgbClr val="1E293B"/>
+                </a:solidFill>
+                <a:latin typeface="Calibri"/>
+              </a:defRPr>
+            </a:pPr>
+            <a:r>
+              <a:t>2. Collect 50–100 operational cycles from normal BESS operation</a:t>
+            </a:r>
+          </a:p>
+          <a:p>
+            <a:pPr algn="l">
+              <a:spcBef>
+                <a:spcPts val="1000"/>
+              </a:spcBef>
+              <a:defRPr sz="2000" b="0">
+                <a:solidFill>
+                  <a:srgbClr val="1E293B"/>
+                </a:solidFill>
+                <a:latin typeface="Calibri"/>
+              </a:defRPr>
+            </a:pPr>
+            <a:r>
+              <a:t>3. Fit a new isotonic regression on these cycles</a:t>
+            </a:r>
+          </a:p>
+          <a:p>
+            <a:pPr algn="l">
+              <a:spcBef>
+                <a:spcPts val="1000"/>
+              </a:spcBef>
+              <a:defRPr sz="2000" b="0">
+                <a:solidFill>
+                  <a:srgbClr val="1E293B"/>
+                </a:solidFill>
+                <a:latin typeface="Calibri"/>
+              </a:defRPr>
+            </a:pPr>
+            <a:r>
+              <a:t>4. Deploy the recalibrated model — no base classifier retraining needed</a:t>
+            </a:r>
+          </a:p>
+        </p:txBody>
+      </p:sp>
+      <p:sp>
+        <p:nvSpPr>
+          <p:cNvPr id="6" name="TextBox 5"/>
+          <p:cNvSpPr txBox="1"/>
+          <p:nvPr/>
+        </p:nvSpPr>
+        <p:spPr>
+          <a:xfrm>
+            <a:off x="731520" y="4389120"/>
+            <a:ext cx="6858000" cy="365760"/>
+          </a:xfrm>
+          <a:prstGeom prst="rect">
+            <a:avLst/>
+          </a:prstGeom>
+          <a:noFill/>
+        </p:spPr>
+        <p:txBody>
+          <a:bodyPr wrap="square">
+            <a:spAutoFit/>
+          </a:bodyPr>
+          <a:lstStyle/>
+          <a:p>
+            <a:pPr algn="l">
+              <a:defRPr sz="1400" b="0">
+                <a:solidFill>
+                  <a:srgbClr val="64748B"/>
+                </a:solidFill>
+                <a:latin typeface="Calibri"/>
+              </a:defRPr>
+            </a:pPr>
+            <a:r>
+              <a:t>No original training data required · No additional feature engineering</a:t>
+            </a:r>
+          </a:p>
+        </p:txBody>
+      </p:sp>
+      <p:sp>
+        <p:nvSpPr>
+          <p:cNvPr id="7" name="Rounded Rectangle 6"/>
+          <p:cNvSpPr/>
+          <p:nvPr/>
+        </p:nvSpPr>
+        <p:spPr>
+          <a:xfrm>
+            <a:off x="8229600" y="1828800"/>
+            <a:ext cx="3200400" cy="1828800"/>
+          </a:xfrm>
+          <a:prstGeom prst="roundRect">
+            <a:avLst/>
+          </a:prstGeom>
+          <a:solidFill>
+            <a:srgbClr val="FFFFFF"/>
+          </a:solidFill>
+          <a:ln w="12700">
+            <a:solidFill>
+              <a:srgbClr val="E2E8F0"/>
+            </a:solidFill>
+          </a:ln>
+        </p:spPr>
+        <p:style>
+          <a:lnRef idx="1">
+            <a:schemeClr val="accent1"/>
+          </a:lnRef>
+          <a:fillRef idx="3">
+            <a:schemeClr val="accent1"/>
+          </a:fillRef>
+          <a:effectRef idx="2">
+            <a:schemeClr val="accent1"/>
+          </a:effectRef>
+          <a:fontRef idx="minor">
+            <a:schemeClr val="lt1"/>
+          </a:fontRef>
+        </p:style>
+        <p:txBody>
+          <a:bodyPr rtlCol="0" anchor="ctr"/>
+          <a:lstStyle/>
+          <a:p>
+            <a:pPr algn="ctr"/>
+          </a:p>
+        </p:txBody>
+      </p:sp>
+      <p:sp>
+        <p:nvSpPr>
+          <p:cNvPr id="8" name="TextBox 7"/>
+          <p:cNvSpPr txBox="1"/>
+          <p:nvPr/>
+        </p:nvSpPr>
+        <p:spPr>
+          <a:xfrm>
+            <a:off x="8412480" y="2011680"/>
+            <a:ext cx="2834640" cy="548640"/>
+          </a:xfrm>
+          <a:prstGeom prst="rect">
+            <a:avLst/>
+          </a:prstGeom>
+          <a:noFill/>
+        </p:spPr>
+        <p:txBody>
+          <a:bodyPr wrap="square">
+            <a:spAutoFit/>
+          </a:bodyPr>
+          <a:lstStyle/>
+          <a:p>
+            <a:pPr algn="ctr">
+              <a:defRPr sz="4800" b="1">
+                <a:solidFill>
+                  <a:srgbClr val="16A34A"/>
+                </a:solidFill>
+                <a:latin typeface="Calibri"/>
+              </a:defRPr>
+            </a:pPr>
+            <a:r>
+              <a:t>10%</a:t>
+            </a:r>
+          </a:p>
+        </p:txBody>
+      </p:sp>
+      <p:sp>
+        <p:nvSpPr>
+          <p:cNvPr id="9" name="TextBox 8"/>
+          <p:cNvSpPr txBox="1"/>
+          <p:nvPr/>
+        </p:nvSpPr>
+        <p:spPr>
+          <a:xfrm>
+            <a:off x="8412480" y="2560320"/>
+            <a:ext cx="2834640" cy="365760"/>
+          </a:xfrm>
+          <a:prstGeom prst="rect">
+            <a:avLst/>
+          </a:prstGeom>
+          <a:noFill/>
+        </p:spPr>
+        <p:txBody>
+          <a:bodyPr wrap="square">
+            <a:spAutoFit/>
+          </a:bodyPr>
+          <a:lstStyle/>
+          <a:p>
+            <a:pPr algn="ctr">
+              <a:defRPr sz="1600" b="0">
+                <a:solidFill>
+                  <a:srgbClr val="64748B"/>
+                </a:solidFill>
+                <a:latin typeface="Calibri"/>
+              </a:defRPr>
+            </a:pPr>
+            <a:r>
+              <a:t>operational sample suffices</a:t>
+            </a:r>
+          </a:p>
+        </p:txBody>
+      </p:sp>
+      <p:sp>
+        <p:nvSpPr>
+          <p:cNvPr id="10" name="TextBox 9"/>
+          <p:cNvSpPr txBox="1"/>
+          <p:nvPr/>
+        </p:nvSpPr>
+        <p:spPr>
+          <a:xfrm>
+            <a:off x="10241280" y="6400800"/>
+            <a:ext cx="1371600" cy="274320"/>
+          </a:xfrm>
+          <a:prstGeom prst="rect">
+            <a:avLst/>
+          </a:prstGeom>
+          <a:noFill/>
+        </p:spPr>
+        <p:txBody>
+          <a:bodyPr wrap="square">
+            <a:spAutoFit/>
+          </a:bodyPr>
+          <a:lstStyle/>
+          <a:p>
+            <a:pPr algn="r">
+              <a:defRPr sz="1000" b="0">
+                <a:solidFill>
+                  <a:srgbClr val="64748B"/>
+                </a:solidFill>
+                <a:latin typeface="Calibri"/>
+              </a:defRPr>
+            </a:pPr>
+            <a:r>
+              <a:t>13 / 14</a:t>
+            </a:r>
+          </a:p>
+        </p:txBody>
+      </p:sp>
+    </p:spTree>
+  </p:cSld>
+  <p:clrMapOvr>
+    <a:masterClrMapping/>
+  </p:clrMapOvr>
+</p:sld>
+</file>
+
+<file path=ppt/slides/slide14.xml><?xml version="1.0" encoding="utf-8"?>
 <p:sld xmlns:a="http://schemas.openxmlformats.org/drawingml/2006/main" xmlns:p="http://schemas.openxmlformats.org/presentationml/2006/main" xmlns:r="http://schemas.openxmlformats.org/officeDocument/2006/relationships">
   <p:cSld>
     <p:bg>
@@ -5364,7 +5703,7 @@
               </a:defRPr>
             </a:pPr>
             <a:r>
-              <a:t>11 / 11</a:t>
+              <a:t>14 / 14</a:t>
             </a:r>
           </a:p>
         </p:txBody>
@@ -5766,7 +6105,7 @@
               </a:defRPr>
             </a:pPr>
             <a:r>
-              <a:t>2 / 11</a:t>
+              <a:t>2 / 14</a:t>
             </a:r>
           </a:p>
         </p:txBody>
@@ -5987,7 +6326,7 @@
               </a:defRPr>
             </a:pPr>
             <a:r>
-              <a:t>3 / 11</a:t>
+              <a:t>3 / 14</a:t>
             </a:r>
           </a:p>
         </p:txBody>
@@ -6597,7 +6936,7 @@
               </a:defRPr>
             </a:pPr>
             <a:r>
-              <a:t>4 / 11</a:t>
+              <a:t>4 / 14</a:t>
             </a:r>
           </a:p>
         </p:txBody>
@@ -7454,7 +7793,7 @@
               </a:defRPr>
             </a:pPr>
             <a:r>
-              <a:t>5 / 11</a:t>
+              <a:t>5 / 14</a:t>
             </a:r>
           </a:p>
         </p:txBody>
@@ -7961,7 +8300,7 @@
               </a:defRPr>
             </a:pPr>
             <a:r>
-              <a:t>6 / 11</a:t>
+              <a:t>6 / 14</a:t>
             </a:r>
           </a:p>
         </p:txBody>
@@ -8198,7 +8537,7 @@
               </a:defRPr>
             </a:pPr>
             <a:r>
-              <a:t>7 / 11</a:t>
+              <a:t>7 / 14</a:t>
             </a:r>
           </a:p>
         </p:txBody>
@@ -8399,7 +8738,7 @@
               </a:defRPr>
             </a:pPr>
             <a:r>
-              <a:t>9 / 11</a:t>
+              <a:t>8 / 14</a:t>
             </a:r>
           </a:p>
         </p:txBody>
@@ -8620,7 +8959,7 @@
               </a:defRPr>
             </a:pPr>
             <a:r>
-              <a:t>7 / 11</a:t>
+              <a:t>9 / 14</a:t>
             </a:r>
           </a:p>
         </p:txBody>

</xml_diff>

<commit_message>
Fix PPTX layout: reposition SHAP caption, adjust slide 10 title spacing, 14-slide numbering
</commit_message>
<xml_diff>
--- a/opendesign/mockups/conference-b-deck/robustness_presentation.pptx
+++ b/opendesign/mockups/conference-b-deck/robustness_presentation.pptx
@@ -3418,7 +3418,7 @@
         <p:spPr>
           <a:xfrm>
             <a:off x="731520" y="640080"/>
-            <a:ext cx="7315200" cy="548640"/>
+            <a:ext cx="7315200" cy="457200"/>
           </a:xfrm>
           <a:prstGeom prst="rect">
             <a:avLst/>
@@ -3453,8 +3453,8 @@
         </p:nvSpPr>
         <p:spPr>
           <a:xfrm>
-            <a:off x="731520" y="914400"/>
-            <a:ext cx="4754880" cy="457200"/>
+            <a:off x="731520" y="1188720"/>
+            <a:ext cx="4754880" cy="365760"/>
           </a:xfrm>
           <a:prstGeom prst="rect">
             <a:avLst/>
@@ -3490,7 +3490,7 @@
           <p:nvPr/>
         </p:nvGraphicFramePr>
         <p:xfrm>
-          <a:off x="731520" y="1554480"/>
+          <a:off x="731520" y="1737360"/>
           <a:ext cx="5669280" cy="2286000"/>
         </p:xfrm>
         <a:graphic>
@@ -5347,8 +5347,8 @@
         </p:nvSpPr>
         <p:spPr>
           <a:xfrm>
-            <a:off x="8412480" y="2011680"/>
-            <a:ext cx="2834640" cy="548640"/>
+            <a:off x="8412480" y="1828800"/>
+            <a:ext cx="2834640" cy="457200"/>
           </a:xfrm>
           <a:prstGeom prst="rect">
             <a:avLst/>
@@ -5362,7 +5362,7 @@
           <a:lstStyle/>
           <a:p>
             <a:pPr algn="ctr">
-              <a:defRPr sz="4800" b="1">
+              <a:defRPr sz="4200" b="1">
                 <a:solidFill>
                   <a:srgbClr val="16A34A"/>
                 </a:solidFill>
@@ -5383,8 +5383,8 @@
         </p:nvSpPr>
         <p:spPr>
           <a:xfrm>
-            <a:off x="8412480" y="2560320"/>
-            <a:ext cx="2834640" cy="365760"/>
+            <a:off x="8412480" y="2286000"/>
+            <a:ext cx="2834640" cy="274320"/>
           </a:xfrm>
           <a:prstGeom prst="rect">
             <a:avLst/>
@@ -5406,7 +5406,7 @@
               </a:defRPr>
             </a:pPr>
             <a:r>
-              <a:t>operational sample suffices</a:t>
+              <a:t>operational sample</a:t>
             </a:r>
           </a:p>
         </p:txBody>
@@ -5414,6 +5414,78 @@
       <p:sp>
         <p:nvSpPr>
           <p:cNvPr id="10" name="TextBox 9"/>
+          <p:cNvSpPr txBox="1"/>
+          <p:nvPr/>
+        </p:nvSpPr>
+        <p:spPr>
+          <a:xfrm>
+            <a:off x="8412480" y="2651760"/>
+            <a:ext cx="2834640" cy="274320"/>
+          </a:xfrm>
+          <a:prstGeom prst="rect">
+            <a:avLst/>
+          </a:prstGeom>
+          <a:noFill/>
+        </p:spPr>
+        <p:txBody>
+          <a:bodyPr wrap="square">
+            <a:spAutoFit/>
+          </a:bodyPr>
+          <a:lstStyle/>
+          <a:p>
+            <a:pPr algn="ctr">
+              <a:defRPr sz="1400" b="0">
+                <a:solidFill>
+                  <a:srgbClr val="64748B"/>
+                </a:solidFill>
+                <a:latin typeface="Calibri"/>
+              </a:defRPr>
+            </a:pPr>
+            <a:r>
+              <a:t>at the elbow of</a:t>
+            </a:r>
+          </a:p>
+        </p:txBody>
+      </p:sp>
+      <p:sp>
+        <p:nvSpPr>
+          <p:cNvPr id="11" name="TextBox 10"/>
+          <p:cNvSpPr txBox="1"/>
+          <p:nvPr/>
+        </p:nvSpPr>
+        <p:spPr>
+          <a:xfrm>
+            <a:off x="8412480" y="2926080"/>
+            <a:ext cx="2834640" cy="274320"/>
+          </a:xfrm>
+          <a:prstGeom prst="rect">
+            <a:avLst/>
+          </a:prstGeom>
+          <a:noFill/>
+        </p:spPr>
+        <p:txBody>
+          <a:bodyPr wrap="square">
+            <a:spAutoFit/>
+          </a:bodyPr>
+          <a:lstStyle/>
+          <a:p>
+            <a:pPr algn="ctr">
+              <a:defRPr sz="1400" b="0">
+                <a:solidFill>
+                  <a:srgbClr val="64748B"/>
+                </a:solidFill>
+                <a:latin typeface="Calibri"/>
+              </a:defRPr>
+            </a:pPr>
+            <a:r>
+              <a:t>the ECE curve</a:t>
+            </a:r>
+          </a:p>
+        </p:txBody>
+      </p:sp>
+      <p:sp>
+        <p:nvSpPr>
+          <p:cNvPr id="12" name="TextBox 11"/>
           <p:cNvSpPr txBox="1"/>
           <p:nvPr/>
         </p:nvSpPr>
@@ -8463,7 +8535,7 @@
         <p:spPr>
           <a:xfrm>
             <a:off x="1371600" y="1188720"/>
-            <a:ext cx="9418320" cy="3616574"/>
+            <a:ext cx="9144000" cy="3511237"/>
           </a:xfrm>
           <a:prstGeom prst="rect">
             <a:avLst/>
@@ -8478,8 +8550,8 @@
         </p:nvSpPr>
         <p:spPr>
           <a:xfrm>
-            <a:off x="1371600" y="6217920"/>
-            <a:ext cx="9144000" cy="365760"/>
+            <a:off x="1371600" y="5303520"/>
+            <a:ext cx="9144000" cy="731520"/>
           </a:xfrm>
           <a:prstGeom prst="rect">
             <a:avLst/>

</xml_diff>

<commit_message>
Add temperature scaling, domain randomization, related work, ORCID, paper edits
- Temperature scaling (scipy L-BFGS-B on logits) added to run_robustness.py, column ece_recal_temp
- Domain randomization: train_domain_rand.py + run_domain_rand.py + F_DR_Comparison.png
- Paper: new Fig 8 (DR), ORCID, related work refs, significance test (Wilcoxon), 5-seed note, temperature column in recal table, compute cost section, expanded limitations
- PPTX updated: 15 slides (new DR slide), temperature column in recal table
- PDF rebuilt with tectonic
</commit_message>
<xml_diff>
--- a/opendesign/mockups/conference-b-deck/robustness_presentation.pptx
+++ b/opendesign/mockups/conference-b-deck/robustness_presentation.pptx
@@ -19,6 +19,7 @@
     <p:sldId id="267" r:id="rId18"/>
     <p:sldId id="268" r:id="rId19"/>
     <p:sldId id="269" r:id="rId20"/>
+    <p:sldId id="270" r:id="rId21"/>
   </p:sldIdLst>
   <p:sldSz cx="12192000" cy="6858000" type="screen4x3"/>
   <p:notesSz cx="6858000" cy="9144000"/>
@@ -3299,7 +3300,7 @@
               </a:defRPr>
             </a:pPr>
             <a:r>
-              <a:t>1 / 14</a:t>
+              <a:t>1 / 15</a:t>
             </a:r>
           </a:p>
         </p:txBody>
@@ -3491,7 +3492,7 @@
         </p:nvGraphicFramePr>
         <p:xfrm>
           <a:off x="731520" y="1737360"/>
-          <a:ext cx="5669280" cy="2286000"/>
+          <a:ext cx="6583680" cy="2286000"/>
         </p:xfrm>
         <a:graphic>
           <a:graphicData uri="http://schemas.openxmlformats.org/drawingml/2006/table">
@@ -3500,11 +3501,12 @@
                 <a:tableStyleId>{5C22544A-7EE6-4342-B048-85BDC9FD1C3A}</a:tableStyleId>
               </a:tblPr>
               <a:tblGrid>
-                <a:gridCol w="1133856"/>
-                <a:gridCol w="1133856"/>
-                <a:gridCol w="1133856"/>
-                <a:gridCol w="1133856"/>
-                <a:gridCol w="1133856"/>
+                <a:gridCol w="1097280"/>
+                <a:gridCol w="1097280"/>
+                <a:gridCol w="1097280"/>
+                <a:gridCol w="1097280"/>
+                <a:gridCol w="1097280"/>
+                <a:gridCol w="1097280"/>
               </a:tblGrid>
               <a:tr h="457200">
                 <a:tc>
@@ -3602,6 +3604,26 @@
                       </a:pPr>
                       <a:r>
                         <a:t>Platt</a:t>
+                      </a:r>
+                    </a:p>
+                  </a:txBody>
+                  <a:tcPr/>
+                </a:tc>
+                <a:tc>
+                  <a:txBody>
+                    <a:bodyPr/>
+                    <a:lstStyle/>
+                    <a:p>
+                      <a:pPr>
+                        <a:defRPr sz="1200" b="1">
+                          <a:solidFill>
+                            <a:srgbClr val="0F172A"/>
+                          </a:solidFill>
+                          <a:latin typeface="Calibri"/>
+                        </a:defRPr>
+                      </a:pPr>
+                      <a:r>
+                        <a:t>Temp.</a:t>
                       </a:r>
                     </a:p>
                   </a:txBody>
@@ -3709,6 +3731,26 @@
                   </a:txBody>
                   <a:tcPr/>
                 </a:tc>
+                <a:tc>
+                  <a:txBody>
+                    <a:bodyPr/>
+                    <a:lstStyle/>
+                    <a:p>
+                      <a:pPr>
+                        <a:defRPr sz="1200" b="1">
+                          <a:solidFill>
+                            <a:srgbClr val="16A34A"/>
+                          </a:solidFill>
+                          <a:latin typeface="Calibri"/>
+                        </a:defRPr>
+                      </a:pPr>
+                      <a:r>
+                        <a:t>0.066±0.024</a:t>
+                      </a:r>
+                    </a:p>
+                  </a:txBody>
+                  <a:tcPr/>
+                </a:tc>
               </a:tr>
               <a:tr h="457200">
                 <a:tc>
@@ -3806,6 +3848,26 @@
                       </a:pPr>
                       <a:r>
                         <a:t>0.083±0.037</a:t>
+                      </a:r>
+                    </a:p>
+                  </a:txBody>
+                  <a:tcPr/>
+                </a:tc>
+                <a:tc>
+                  <a:txBody>
+                    <a:bodyPr/>
+                    <a:lstStyle/>
+                    <a:p>
+                      <a:pPr>
+                        <a:defRPr sz="1200" b="1">
+                          <a:solidFill>
+                            <a:srgbClr val="16A34A"/>
+                          </a:solidFill>
+                          <a:latin typeface="Calibri"/>
+                        </a:defRPr>
+                      </a:pPr>
+                      <a:r>
+                        <a:t>0.087±0.022</a:t>
                       </a:r>
                     </a:p>
                   </a:txBody>
@@ -3913,6 +3975,26 @@
                   </a:txBody>
                   <a:tcPr/>
                 </a:tc>
+                <a:tc>
+                  <a:txBody>
+                    <a:bodyPr/>
+                    <a:lstStyle/>
+                    <a:p>
+                      <a:pPr>
+                        <a:defRPr sz="1200" b="1">
+                          <a:solidFill>
+                            <a:srgbClr val="16A34A"/>
+                          </a:solidFill>
+                          <a:latin typeface="Calibri"/>
+                        </a:defRPr>
+                      </a:pPr>
+                      <a:r>
+                        <a:t>0.104±0.019</a:t>
+                      </a:r>
+                    </a:p>
+                  </a:txBody>
+                  <a:tcPr/>
+                </a:tc>
               </a:tr>
               <a:tr h="457200">
                 <a:tc>
@@ -4015,6 +4097,26 @@
                   </a:txBody>
                   <a:tcPr/>
                 </a:tc>
+                <a:tc>
+                  <a:txBody>
+                    <a:bodyPr/>
+                    <a:lstStyle/>
+                    <a:p>
+                      <a:pPr>
+                        <a:defRPr sz="1200" b="1">
+                          <a:solidFill>
+                            <a:srgbClr val="16A34A"/>
+                          </a:solidFill>
+                          <a:latin typeface="Calibri"/>
+                        </a:defRPr>
+                      </a:pPr>
+                      <a:r>
+                        <a:t>0.137±0.026</a:t>
+                      </a:r>
+                    </a:p>
+                  </a:txBody>
+                  <a:tcPr/>
+                </a:tc>
               </a:tr>
             </a:tbl>
           </a:graphicData>
@@ -4029,7 +4131,7 @@
         <p:spPr>
           <a:xfrm>
             <a:off x="731520" y="4114800"/>
-            <a:ext cx="5669280" cy="274320"/>
+            <a:ext cx="6400800" cy="274320"/>
           </a:xfrm>
           <a:prstGeom prst="rect">
             <a:avLst/>
@@ -4051,7 +4153,7 @@
               </a:defRPr>
             </a:pPr>
             <a:r>
-              <a:t>Isotonic and Platt perform comparably — recalibration itself matters, not the method</a:t>
+              <a:t>All three methods comparable at H=10–30; temperature scaling underperforms at H=50</a:t>
             </a:r>
           </a:p>
         </p:txBody>
@@ -4072,8 +4174,8 @@
         </p:blipFill>
         <p:spPr>
           <a:xfrm>
-            <a:off x="6400800" y="914400"/>
-            <a:ext cx="5029200" cy="4114800"/>
+            <a:off x="6858000" y="914400"/>
+            <a:ext cx="4572000" cy="3740727"/>
           </a:xfrm>
           <a:prstGeom prst="rect">
             <a:avLst/>
@@ -4111,7 +4213,7 @@
               </a:defRPr>
             </a:pPr>
             <a:r>
-              <a:t>10 / 14</a:t>
+              <a:t>10 / 15</a:t>
             </a:r>
           </a:p>
         </p:txBody>
@@ -4348,7 +4450,7 @@
               </a:defRPr>
             </a:pPr>
             <a:r>
-              <a:t>11 / 14</a:t>
+              <a:t>11 / 15</a:t>
             </a:r>
           </a:p>
         </p:txBody>
@@ -4453,7 +4555,7 @@
               </a:defRPr>
             </a:pPr>
             <a:r>
-              <a:t>FRAMEWORK</a:t>
+              <a:t>ROBUSTNESS</a:t>
             </a:r>
           </a:p>
         </p:txBody>
@@ -4489,31 +4591,127 @@
               </a:defRPr>
             </a:pPr>
             <a:r>
-              <a:t>Three operating zones</a:t>
-            </a:r>
-          </a:p>
-        </p:txBody>
-      </p:sp>
-      <p:sp>
-        <p:nvSpPr>
-          <p:cNvPr id="5" name="Rounded Rectangle 4"/>
+              <a:t>Domain randomization: modest extra gain</a:t>
+            </a:r>
+          </a:p>
+        </p:txBody>
+      </p:sp>
+      <p:sp>
+        <p:nvSpPr>
+          <p:cNvPr id="5" name="TextBox 4"/>
+          <p:cNvSpPr txBox="1"/>
+          <p:nvPr/>
+        </p:nvSpPr>
+        <p:spPr>
+          <a:xfrm>
+            <a:off x="731520" y="1188720"/>
+            <a:ext cx="5486400" cy="365760"/>
+          </a:xfrm>
+          <a:prstGeom prst="rect">
+            <a:avLst/>
+          </a:prstGeom>
+          <a:noFill/>
+        </p:spPr>
+        <p:txBody>
+          <a:bodyPr wrap="square">
+            <a:spAutoFit/>
+          </a:bodyPr>
+          <a:lstStyle/>
+          <a:p>
+            <a:pPr algn="l">
+              <a:defRPr sz="1600" b="0">
+                <a:solidFill>
+                  <a:srgbClr val="1E293B"/>
+                </a:solidFill>
+                <a:latin typeface="Calibri"/>
+              </a:defRPr>
+            </a:pPr>
+            <a:r>
+              <a:t>Training on perturbed data provides additional protection at longer horizons.</a:t>
+            </a:r>
+          </a:p>
+        </p:txBody>
+      </p:sp>
+      <p:pic>
+        <p:nvPicPr>
+          <p:cNvPr id="6" name="Picture 5" descr="fig_dr.png"/>
+          <p:cNvPicPr>
+            <a:picLocks noChangeAspect="1"/>
+          </p:cNvPicPr>
+          <p:nvPr/>
+        </p:nvPicPr>
+        <p:blipFill>
+          <a:blip r:embed="rId2"/>
+          <a:stretch>
+            <a:fillRect/>
+          </a:stretch>
+        </p:blipFill>
+        <p:spPr>
+          <a:xfrm>
+            <a:off x="457200" y="1737360"/>
+            <a:ext cx="6858000" cy="3086100"/>
+          </a:xfrm>
+          <a:prstGeom prst="rect">
+            <a:avLst/>
+          </a:prstGeom>
+        </p:spPr>
+      </p:pic>
+      <p:sp>
+        <p:nvSpPr>
+          <p:cNvPr id="7" name="TextBox 6"/>
+          <p:cNvSpPr txBox="1"/>
+          <p:nvPr/>
+        </p:nvSpPr>
+        <p:spPr>
+          <a:xfrm>
+            <a:off x="457200" y="5852160"/>
+            <a:ext cx="6858000" cy="365760"/>
+          </a:xfrm>
+          <a:prstGeom prst="rect">
+            <a:avLst/>
+          </a:prstGeom>
+          <a:noFill/>
+        </p:spPr>
+        <p:txBody>
+          <a:bodyPr wrap="square">
+            <a:spAutoFit/>
+          </a:bodyPr>
+          <a:lstStyle/>
+          <a:p>
+            <a:pPr algn="ctr">
+              <a:defRPr sz="1300" b="0">
+                <a:solidFill>
+                  <a:srgbClr val="64748B"/>
+                </a:solidFill>
+                <a:latin typeface="Calibri"/>
+              </a:defRPr>
+            </a:pPr>
+            <a:r>
+              <a:t>DR+H=50 ECE=0.047 vs. standard+isotonic H=50 ECE=0.087 (45% reduction). Minimal gain at H=10.</a:t>
+            </a:r>
+          </a:p>
+        </p:txBody>
+      </p:sp>
+      <p:sp>
+        <p:nvSpPr>
+          <p:cNvPr id="8" name="Rounded Rectangle 7"/>
           <p:cNvSpPr/>
           <p:nvPr/>
         </p:nvSpPr>
         <p:spPr>
           <a:xfrm>
-            <a:off x="731520" y="2286000"/>
-            <a:ext cx="3291840" cy="2743200"/>
+            <a:off x="7772400" y="1371600"/>
+            <a:ext cx="3657600" cy="4114800"/>
           </a:xfrm>
           <a:prstGeom prst="roundRect">
             <a:avLst/>
           </a:prstGeom>
           <a:solidFill>
-            <a:srgbClr val="F0FDF4"/>
+            <a:srgbClr val="FFFFFF"/>
           </a:solidFill>
           <a:ln w="12700">
             <a:solidFill>
-              <a:srgbClr val="BBF7D0"/>
+              <a:srgbClr val="E2E8F0"/>
             </a:solidFill>
           </a:ln>
         </p:spPr>
@@ -4541,13 +4739,13 @@
       </p:sp>
       <p:sp>
         <p:nvSpPr>
-          <p:cNvPr id="6" name="TextBox 5"/>
+          <p:cNvPr id="9" name="TextBox 8"/>
           <p:cNvSpPr txBox="1"/>
           <p:nvPr/>
         </p:nvSpPr>
         <p:spPr>
           <a:xfrm>
-            <a:off x="731520" y="2560320"/>
+            <a:off x="7955279" y="1554480"/>
             <a:ext cx="3291840" cy="457200"/>
           </a:xfrm>
           <a:prstGeom prst="rect">
@@ -4562,29 +4760,29 @@
           <a:lstStyle/>
           <a:p>
             <a:pPr algn="ctr">
-              <a:defRPr sz="3600" b="1">
-                <a:solidFill>
-                  <a:srgbClr val="16A34A"/>
-                </a:solidFill>
-                <a:latin typeface="Calibri"/>
-              </a:defRPr>
-            </a:pPr>
-            <a:r>
-              <a:t>● Safe</a:t>
-            </a:r>
-          </a:p>
-        </p:txBody>
-      </p:sp>
-      <p:sp>
-        <p:nvSpPr>
-          <p:cNvPr id="7" name="TextBox 6"/>
+              <a:defRPr sz="2200" b="1">
+                <a:solidFill>
+                  <a:srgbClr val="0F172A"/>
+                </a:solidFill>
+                <a:latin typeface="Calibri"/>
+              </a:defRPr>
+            </a:pPr>
+            <a:r>
+              <a:t>Trade-off</a:t>
+            </a:r>
+          </a:p>
+        </p:txBody>
+      </p:sp>
+      <p:sp>
+        <p:nvSpPr>
+          <p:cNvPr id="10" name="TextBox 9"/>
           <p:cNvSpPr txBox="1"/>
           <p:nvPr/>
         </p:nvSpPr>
         <p:spPr>
           <a:xfrm>
-            <a:off x="731520" y="3108960"/>
-            <a:ext cx="3291840" cy="365760"/>
+            <a:off x="7955279" y="2194560"/>
+            <a:ext cx="3291840" cy="2743200"/>
           </a:xfrm>
           <a:prstGeom prst="rect">
             <a:avLst/>
@@ -4597,8 +4795,8 @@
           </a:bodyPr>
           <a:lstStyle/>
           <a:p>
-            <a:pPr algn="ctr">
-              <a:defRPr sz="2200" b="1">
+            <a:pPr algn="l">
+              <a:defRPr sz="1500" b="0">
                 <a:solidFill>
                   <a:srgbClr val="1E293B"/>
                 </a:solidFill>
@@ -4606,21 +4804,69 @@
               </a:defRPr>
             </a:pPr>
             <a:r>
-              <a:t>ECE &lt; 0.05</a:t>
-            </a:r>
-          </a:p>
-        </p:txBody>
-      </p:sp>
-      <p:sp>
-        <p:nvSpPr>
-          <p:cNvPr id="8" name="TextBox 7"/>
+              <a:t>• 4× training data overhead</a:t>
+            </a:r>
+          </a:p>
+          <a:p>
+            <a:pPr algn="l">
+              <a:spcBef>
+                <a:spcPts val="600"/>
+              </a:spcBef>
+              <a:defRPr sz="1500" b="0">
+                <a:solidFill>
+                  <a:srgbClr val="1E293B"/>
+                </a:solidFill>
+                <a:latin typeface="Calibri"/>
+              </a:defRPr>
+            </a:pPr>
+            <a:r>
+              <a:t>• ~10 min extra training</a:t>
+            </a:r>
+          </a:p>
+          <a:p>
+            <a:pPr algn="l">
+              <a:spcBef>
+                <a:spcPts val="600"/>
+              </a:spcBef>
+              <a:defRPr sz="1500" b="0">
+                <a:solidFill>
+                  <a:srgbClr val="1E293B"/>
+                </a:solidFill>
+                <a:latin typeface="Calibri"/>
+              </a:defRPr>
+            </a:pPr>
+            <a:r>
+              <a:t>• Same base classifier</a:t>
+            </a:r>
+          </a:p>
+          <a:p>
+            <a:pPr algn="l">
+              <a:spcBef>
+                <a:spcPts val="600"/>
+              </a:spcBef>
+              <a:defRPr sz="1500" b="0">
+                <a:solidFill>
+                  <a:srgbClr val="1E293B"/>
+                </a:solidFill>
+                <a:latin typeface="Calibri"/>
+              </a:defRPr>
+            </a:pPr>
+            <a:r>
+              <a:t>• Harder to explain in ops</a:t>
+            </a:r>
+          </a:p>
+        </p:txBody>
+      </p:sp>
+      <p:sp>
+        <p:nvSpPr>
+          <p:cNvPr id="11" name="TextBox 10"/>
           <p:cNvSpPr txBox="1"/>
           <p:nvPr/>
         </p:nvSpPr>
         <p:spPr>
           <a:xfrm>
-            <a:off x="914400" y="3474720"/>
-            <a:ext cx="2926080" cy="548640"/>
+            <a:off x="7955279" y="4572000"/>
+            <a:ext cx="3291840" cy="457200"/>
           </a:xfrm>
           <a:prstGeom prst="rect">
             <a:avLst/>
@@ -4634,74 +4880,33 @@
           <a:lstStyle/>
           <a:p>
             <a:pPr algn="ctr">
-              <a:defRPr sz="1400" b="0">
-                <a:solidFill>
-                  <a:srgbClr val="64748B"/>
-                </a:solidFill>
-                <a:latin typeface="Calibri"/>
-              </a:defRPr>
-            </a:pPr>
-            <a:r>
-              <a:t>Clean lab conditions only</a:t>
-            </a:r>
-          </a:p>
-        </p:txBody>
-      </p:sp>
-      <p:sp>
-        <p:nvSpPr>
-          <p:cNvPr id="9" name="Rounded Rectangle 8"/>
-          <p:cNvSpPr/>
-          <p:nvPr/>
-        </p:nvSpPr>
-        <p:spPr>
-          <a:xfrm>
-            <a:off x="4389120" y="2286000"/>
-            <a:ext cx="3291840" cy="2743200"/>
-          </a:xfrm>
-          <a:prstGeom prst="roundRect">
-            <a:avLst/>
-          </a:prstGeom>
-          <a:solidFill>
-            <a:srgbClr val="FFFBEB"/>
-          </a:solidFill>
-          <a:ln w="12700">
-            <a:solidFill>
-              <a:srgbClr val="FDE68A"/>
-            </a:solidFill>
-          </a:ln>
-        </p:spPr>
-        <p:style>
-          <a:lnRef idx="1">
-            <a:schemeClr val="accent1"/>
-          </a:lnRef>
-          <a:fillRef idx="3">
-            <a:schemeClr val="accent1"/>
-          </a:fillRef>
-          <a:effectRef idx="2">
-            <a:schemeClr val="accent1"/>
-          </a:effectRef>
-          <a:fontRef idx="minor">
-            <a:schemeClr val="lt1"/>
-          </a:fontRef>
-        </p:style>
-        <p:txBody>
-          <a:bodyPr rtlCol="0" anchor="ctr"/>
-          <a:lstStyle/>
-          <a:p>
-            <a:pPr algn="ctr"/>
-          </a:p>
-        </p:txBody>
-      </p:sp>
-      <p:sp>
-        <p:nvSpPr>
-          <p:cNvPr id="10" name="TextBox 9"/>
+              <a:defRPr sz="1400" b="1">
+                <a:solidFill>
+                  <a:srgbClr val="16A34A"/>
+                </a:solidFill>
+                <a:latin typeface="Calibri"/>
+              </a:defRPr>
+            </a:pPr>
+            <a:r>
+              <a:t>For most deployments:</a:t>
+            </a:r>
+            <a:br/>
+            <a:r>
+              <a:t>recalibration alone suffices</a:t>
+            </a:r>
+          </a:p>
+        </p:txBody>
+      </p:sp>
+      <p:sp>
+        <p:nvSpPr>
+          <p:cNvPr id="12" name="TextBox 11"/>
           <p:cNvSpPr txBox="1"/>
           <p:nvPr/>
         </p:nvSpPr>
         <p:spPr>
           <a:xfrm>
-            <a:off x="4389120" y="2560320"/>
-            <a:ext cx="3291840" cy="457200"/>
+            <a:off x="10241280" y="6400800"/>
+            <a:ext cx="1371600" cy="274320"/>
           </a:xfrm>
           <a:prstGeom prst="rect">
             <a:avLst/>
@@ -4714,311 +4919,6 @@
           </a:bodyPr>
           <a:lstStyle/>
           <a:p>
-            <a:pPr algn="ctr">
-              <a:defRPr sz="3600" b="1">
-                <a:solidFill>
-                  <a:srgbClr val="D97706"/>
-                </a:solidFill>
-                <a:latin typeface="Calibri"/>
-              </a:defRPr>
-            </a:pPr>
-            <a:r>
-              <a:t>● Warning</a:t>
-            </a:r>
-          </a:p>
-        </p:txBody>
-      </p:sp>
-      <p:sp>
-        <p:nvSpPr>
-          <p:cNvPr id="11" name="TextBox 10"/>
-          <p:cNvSpPr txBox="1"/>
-          <p:nvPr/>
-        </p:nvSpPr>
-        <p:spPr>
-          <a:xfrm>
-            <a:off x="4389120" y="3108960"/>
-            <a:ext cx="3291840" cy="365760"/>
-          </a:xfrm>
-          <a:prstGeom prst="rect">
-            <a:avLst/>
-          </a:prstGeom>
-          <a:noFill/>
-        </p:spPr>
-        <p:txBody>
-          <a:bodyPr wrap="square">
-            <a:spAutoFit/>
-          </a:bodyPr>
-          <a:lstStyle/>
-          <a:p>
-            <a:pPr algn="ctr">
-              <a:defRPr sz="2200" b="1">
-                <a:solidFill>
-                  <a:srgbClr val="1E293B"/>
-                </a:solidFill>
-                <a:latin typeface="Calibri"/>
-              </a:defRPr>
-            </a:pPr>
-            <a:r>
-              <a:t>ECE 0.05–0.10</a:t>
-            </a:r>
-          </a:p>
-        </p:txBody>
-      </p:sp>
-      <p:sp>
-        <p:nvSpPr>
-          <p:cNvPr id="12" name="TextBox 11"/>
-          <p:cNvSpPr txBox="1"/>
-          <p:nvPr/>
-        </p:nvSpPr>
-        <p:spPr>
-          <a:xfrm>
-            <a:off x="4572000" y="3474720"/>
-            <a:ext cx="2926080" cy="548640"/>
-          </a:xfrm>
-          <a:prstGeom prst="rect">
-            <a:avLst/>
-          </a:prstGeom>
-          <a:noFill/>
-        </p:spPr>
-        <p:txBody>
-          <a:bodyPr wrap="square">
-            <a:spAutoFit/>
-          </a:bodyPr>
-          <a:lstStyle/>
-          <a:p>
-            <a:pPr algn="ctr">
-              <a:defRPr sz="1400" b="0">
-                <a:solidFill>
-                  <a:srgbClr val="64748B"/>
-                </a:solidFill>
-                <a:latin typeface="Calibri"/>
-              </a:defRPr>
-            </a:pPr>
-            <a:r>
-              <a:t>Recalibrated operation</a:t>
-            </a:r>
-            <a:br/>
-            <a:r>
-              <a:t>10% operational sample</a:t>
-            </a:r>
-          </a:p>
-        </p:txBody>
-      </p:sp>
-      <p:sp>
-        <p:nvSpPr>
-          <p:cNvPr id="13" name="Rounded Rectangle 12"/>
-          <p:cNvSpPr/>
-          <p:nvPr/>
-        </p:nvSpPr>
-        <p:spPr>
-          <a:xfrm>
-            <a:off x="8046720" y="2286000"/>
-            <a:ext cx="3291840" cy="2743200"/>
-          </a:xfrm>
-          <a:prstGeom prst="roundRect">
-            <a:avLst/>
-          </a:prstGeom>
-          <a:solidFill>
-            <a:srgbClr val="FEF2F2"/>
-          </a:solidFill>
-          <a:ln w="12700">
-            <a:solidFill>
-              <a:srgbClr val="FECACA"/>
-            </a:solidFill>
-          </a:ln>
-        </p:spPr>
-        <p:style>
-          <a:lnRef idx="1">
-            <a:schemeClr val="accent1"/>
-          </a:lnRef>
-          <a:fillRef idx="3">
-            <a:schemeClr val="accent1"/>
-          </a:fillRef>
-          <a:effectRef idx="2">
-            <a:schemeClr val="accent1"/>
-          </a:effectRef>
-          <a:fontRef idx="minor">
-            <a:schemeClr val="lt1"/>
-          </a:fontRef>
-        </p:style>
-        <p:txBody>
-          <a:bodyPr rtlCol="0" anchor="ctr"/>
-          <a:lstStyle/>
-          <a:p>
-            <a:pPr algn="ctr"/>
-          </a:p>
-        </p:txBody>
-      </p:sp>
-      <p:sp>
-        <p:nvSpPr>
-          <p:cNvPr id="14" name="TextBox 13"/>
-          <p:cNvSpPr txBox="1"/>
-          <p:nvPr/>
-        </p:nvSpPr>
-        <p:spPr>
-          <a:xfrm>
-            <a:off x="8046720" y="2560320"/>
-            <a:ext cx="3291840" cy="457200"/>
-          </a:xfrm>
-          <a:prstGeom prst="rect">
-            <a:avLst/>
-          </a:prstGeom>
-          <a:noFill/>
-        </p:spPr>
-        <p:txBody>
-          <a:bodyPr wrap="square">
-            <a:spAutoFit/>
-          </a:bodyPr>
-          <a:lstStyle/>
-          <a:p>
-            <a:pPr algn="ctr">
-              <a:defRPr sz="3600" b="1">
-                <a:solidFill>
-                  <a:srgbClr val="DC2626"/>
-                </a:solidFill>
-                <a:latin typeface="Calibri"/>
-              </a:defRPr>
-            </a:pPr>
-            <a:r>
-              <a:t>● Unsafe</a:t>
-            </a:r>
-          </a:p>
-        </p:txBody>
-      </p:sp>
-      <p:sp>
-        <p:nvSpPr>
-          <p:cNvPr id="15" name="TextBox 14"/>
-          <p:cNvSpPr txBox="1"/>
-          <p:nvPr/>
-        </p:nvSpPr>
-        <p:spPr>
-          <a:xfrm>
-            <a:off x="8046720" y="3108960"/>
-            <a:ext cx="3291840" cy="365760"/>
-          </a:xfrm>
-          <a:prstGeom prst="rect">
-            <a:avLst/>
-          </a:prstGeom>
-          <a:noFill/>
-        </p:spPr>
-        <p:txBody>
-          <a:bodyPr wrap="square">
-            <a:spAutoFit/>
-          </a:bodyPr>
-          <a:lstStyle/>
-          <a:p>
-            <a:pPr algn="ctr">
-              <a:defRPr sz="2200" b="1">
-                <a:solidFill>
-                  <a:srgbClr val="1E293B"/>
-                </a:solidFill>
-                <a:latin typeface="Calibri"/>
-              </a:defRPr>
-            </a:pPr>
-            <a:r>
-              <a:t>ECE &gt; 0.10</a:t>
-            </a:r>
-          </a:p>
-        </p:txBody>
-      </p:sp>
-      <p:sp>
-        <p:nvSpPr>
-          <p:cNvPr id="16" name="TextBox 15"/>
-          <p:cNvSpPr txBox="1"/>
-          <p:nvPr/>
-        </p:nvSpPr>
-        <p:spPr>
-          <a:xfrm>
-            <a:off x="8229600" y="3474720"/>
-            <a:ext cx="2926080" cy="548640"/>
-          </a:xfrm>
-          <a:prstGeom prst="rect">
-            <a:avLst/>
-          </a:prstGeom>
-          <a:noFill/>
-        </p:spPr>
-        <p:txBody>
-          <a:bodyPr wrap="square">
-            <a:spAutoFit/>
-          </a:bodyPr>
-          <a:lstStyle/>
-          <a:p>
-            <a:pPr algn="ctr">
-              <a:defRPr sz="1400" b="0">
-                <a:solidFill>
-                  <a:srgbClr val="64748B"/>
-                </a:solidFill>
-                <a:latin typeface="Calibri"/>
-              </a:defRPr>
-            </a:pPr>
-            <a:r>
-              <a:t>Direct deployment under</a:t>
-            </a:r>
-            <a:br/>
-            <a:r>
-              <a:t>any partial cycling (ECE &gt; 0.27)</a:t>
-            </a:r>
-          </a:p>
-        </p:txBody>
-      </p:sp>
-      <p:sp>
-        <p:nvSpPr>
-          <p:cNvPr id="17" name="TextBox 16"/>
-          <p:cNvSpPr txBox="1"/>
-          <p:nvPr/>
-        </p:nvSpPr>
-        <p:spPr>
-          <a:xfrm>
-            <a:off x="731520" y="5303520"/>
-            <a:ext cx="10058400" cy="365760"/>
-          </a:xfrm>
-          <a:prstGeom prst="rect">
-            <a:avLst/>
-          </a:prstGeom>
-          <a:noFill/>
-        </p:spPr>
-        <p:txBody>
-          <a:bodyPr wrap="square">
-            <a:spAutoFit/>
-          </a:bodyPr>
-          <a:lstStyle/>
-          <a:p>
-            <a:pPr algn="ctr">
-              <a:defRPr sz="1600" b="0">
-                <a:solidFill>
-                  <a:srgbClr val="64748B"/>
-                </a:solidFill>
-                <a:latin typeface="Calibri"/>
-              </a:defRPr>
-            </a:pPr>
-            <a:r>
-              <a:t>Direct deployment under partial cycling pushes ECE &gt; 0.27 — firmly in the unsafe zone</a:t>
-            </a:r>
-          </a:p>
-        </p:txBody>
-      </p:sp>
-      <p:sp>
-        <p:nvSpPr>
-          <p:cNvPr id="18" name="TextBox 17"/>
-          <p:cNvSpPr txBox="1"/>
-          <p:nvPr/>
-        </p:nvSpPr>
-        <p:spPr>
-          <a:xfrm>
-            <a:off x="10241280" y="6400800"/>
-            <a:ext cx="1371600" cy="274320"/>
-          </a:xfrm>
-          <a:prstGeom prst="rect">
-            <a:avLst/>
-          </a:prstGeom>
-          <a:noFill/>
-        </p:spPr>
-        <p:txBody>
-          <a:bodyPr wrap="square">
-            <a:spAutoFit/>
-          </a:bodyPr>
-          <a:lstStyle/>
-          <a:p>
             <a:pPr algn="r">
               <a:defRPr sz="1000" b="0">
                 <a:solidFill>
@@ -5028,7 +4928,7 @@
               </a:defRPr>
             </a:pPr>
             <a:r>
-              <a:t>12 / 14</a:t>
+              <a:t>12 / 15</a:t>
             </a:r>
           </a:p>
         </p:txBody>
@@ -5133,7 +5033,7 @@
               </a:defRPr>
             </a:pPr>
             <a:r>
-              <a:t>ACTION</a:t>
+              <a:t>FRAMEWORK</a:t>
             </a:r>
           </a:p>
         </p:txBody>
@@ -5169,151 +5069,31 @@
               </a:defRPr>
             </a:pPr>
             <a:r>
-              <a:t>Practical deployment path</a:t>
-            </a:r>
-          </a:p>
-        </p:txBody>
-      </p:sp>
-      <p:sp>
-        <p:nvSpPr>
-          <p:cNvPr id="5" name="TextBox 4"/>
-          <p:cNvSpPr txBox="1"/>
-          <p:nvPr/>
-        </p:nvSpPr>
-        <p:spPr>
-          <a:xfrm>
-            <a:off x="731520" y="1463040"/>
-            <a:ext cx="6858000" cy="2743200"/>
-          </a:xfrm>
-          <a:prstGeom prst="rect">
-            <a:avLst/>
-          </a:prstGeom>
-          <a:noFill/>
-        </p:spPr>
-        <p:txBody>
-          <a:bodyPr wrap="square">
-            <a:spAutoFit/>
-          </a:bodyPr>
-          <a:lstStyle/>
-          <a:p>
-            <a:pPr algn="l">
-              <a:defRPr sz="2000" b="0">
-                <a:solidFill>
-                  <a:srgbClr val="1E293B"/>
-                </a:solidFill>
-                <a:latin typeface="Calibri"/>
-              </a:defRPr>
-            </a:pPr>
-            <a:r>
-              <a:t>1. Deploy the frozen XGBoost model as-is</a:t>
-            </a:r>
-          </a:p>
-          <a:p>
-            <a:pPr algn="l">
-              <a:spcBef>
-                <a:spcPts val="1000"/>
-              </a:spcBef>
-              <a:defRPr sz="2000" b="0">
-                <a:solidFill>
-                  <a:srgbClr val="1E293B"/>
-                </a:solidFill>
-                <a:latin typeface="Calibri"/>
-              </a:defRPr>
-            </a:pPr>
-            <a:r>
-              <a:t>2. Collect 50–100 operational cycles from normal BESS operation</a:t>
-            </a:r>
-          </a:p>
-          <a:p>
-            <a:pPr algn="l">
-              <a:spcBef>
-                <a:spcPts val="1000"/>
-              </a:spcBef>
-              <a:defRPr sz="2000" b="0">
-                <a:solidFill>
-                  <a:srgbClr val="1E293B"/>
-                </a:solidFill>
-                <a:latin typeface="Calibri"/>
-              </a:defRPr>
-            </a:pPr>
-            <a:r>
-              <a:t>3. Fit a new isotonic regression on these cycles</a:t>
-            </a:r>
-          </a:p>
-          <a:p>
-            <a:pPr algn="l">
-              <a:spcBef>
-                <a:spcPts val="1000"/>
-              </a:spcBef>
-              <a:defRPr sz="2000" b="0">
-                <a:solidFill>
-                  <a:srgbClr val="1E293B"/>
-                </a:solidFill>
-                <a:latin typeface="Calibri"/>
-              </a:defRPr>
-            </a:pPr>
-            <a:r>
-              <a:t>4. Deploy the recalibrated model — no base classifier retraining needed</a:t>
-            </a:r>
-          </a:p>
-        </p:txBody>
-      </p:sp>
-      <p:sp>
-        <p:nvSpPr>
-          <p:cNvPr id="6" name="TextBox 5"/>
-          <p:cNvSpPr txBox="1"/>
-          <p:nvPr/>
-        </p:nvSpPr>
-        <p:spPr>
-          <a:xfrm>
-            <a:off x="731520" y="4389120"/>
-            <a:ext cx="6858000" cy="365760"/>
-          </a:xfrm>
-          <a:prstGeom prst="rect">
-            <a:avLst/>
-          </a:prstGeom>
-          <a:noFill/>
-        </p:spPr>
-        <p:txBody>
-          <a:bodyPr wrap="square">
-            <a:spAutoFit/>
-          </a:bodyPr>
-          <a:lstStyle/>
-          <a:p>
-            <a:pPr algn="l">
-              <a:defRPr sz="1400" b="0">
-                <a:solidFill>
-                  <a:srgbClr val="64748B"/>
-                </a:solidFill>
-                <a:latin typeface="Calibri"/>
-              </a:defRPr>
-            </a:pPr>
-            <a:r>
-              <a:t>No original training data required · No additional feature engineering</a:t>
-            </a:r>
-          </a:p>
-        </p:txBody>
-      </p:sp>
-      <p:sp>
-        <p:nvSpPr>
-          <p:cNvPr id="7" name="Rounded Rectangle 6"/>
+              <a:t>Three operating zones</a:t>
+            </a:r>
+          </a:p>
+        </p:txBody>
+      </p:sp>
+      <p:sp>
+        <p:nvSpPr>
+          <p:cNvPr id="5" name="Rounded Rectangle 4"/>
           <p:cNvSpPr/>
           <p:nvPr/>
         </p:nvSpPr>
         <p:spPr>
           <a:xfrm>
-            <a:off x="8229600" y="1828800"/>
-            <a:ext cx="3200400" cy="1828800"/>
+            <a:off x="731520" y="2286000"/>
+            <a:ext cx="3291840" cy="2743200"/>
           </a:xfrm>
           <a:prstGeom prst="roundRect">
             <a:avLst/>
           </a:prstGeom>
           <a:solidFill>
-            <a:srgbClr val="FFFFFF"/>
+            <a:srgbClr val="F0FDF4"/>
           </a:solidFill>
           <a:ln w="12700">
             <a:solidFill>
-              <a:srgbClr val="E2E8F0"/>
+              <a:srgbClr val="BBF7D0"/>
             </a:solidFill>
           </a:ln>
         </p:spPr>
@@ -5341,14 +5121,86 @@
       </p:sp>
       <p:sp>
         <p:nvSpPr>
+          <p:cNvPr id="6" name="TextBox 5"/>
+          <p:cNvSpPr txBox="1"/>
+          <p:nvPr/>
+        </p:nvSpPr>
+        <p:spPr>
+          <a:xfrm>
+            <a:off x="731520" y="2560320"/>
+            <a:ext cx="3291840" cy="457200"/>
+          </a:xfrm>
+          <a:prstGeom prst="rect">
+            <a:avLst/>
+          </a:prstGeom>
+          <a:noFill/>
+        </p:spPr>
+        <p:txBody>
+          <a:bodyPr wrap="square">
+            <a:spAutoFit/>
+          </a:bodyPr>
+          <a:lstStyle/>
+          <a:p>
+            <a:pPr algn="ctr">
+              <a:defRPr sz="3600" b="1">
+                <a:solidFill>
+                  <a:srgbClr val="16A34A"/>
+                </a:solidFill>
+                <a:latin typeface="Calibri"/>
+              </a:defRPr>
+            </a:pPr>
+            <a:r>
+              <a:t>● Safe</a:t>
+            </a:r>
+          </a:p>
+        </p:txBody>
+      </p:sp>
+      <p:sp>
+        <p:nvSpPr>
+          <p:cNvPr id="7" name="TextBox 6"/>
+          <p:cNvSpPr txBox="1"/>
+          <p:nvPr/>
+        </p:nvSpPr>
+        <p:spPr>
+          <a:xfrm>
+            <a:off x="731520" y="3108960"/>
+            <a:ext cx="3291840" cy="365760"/>
+          </a:xfrm>
+          <a:prstGeom prst="rect">
+            <a:avLst/>
+          </a:prstGeom>
+          <a:noFill/>
+        </p:spPr>
+        <p:txBody>
+          <a:bodyPr wrap="square">
+            <a:spAutoFit/>
+          </a:bodyPr>
+          <a:lstStyle/>
+          <a:p>
+            <a:pPr algn="ctr">
+              <a:defRPr sz="2200" b="1">
+                <a:solidFill>
+                  <a:srgbClr val="1E293B"/>
+                </a:solidFill>
+                <a:latin typeface="Calibri"/>
+              </a:defRPr>
+            </a:pPr>
+            <a:r>
+              <a:t>ECE &lt; 0.05</a:t>
+            </a:r>
+          </a:p>
+        </p:txBody>
+      </p:sp>
+      <p:sp>
+        <p:nvSpPr>
           <p:cNvPr id="8" name="TextBox 7"/>
           <p:cNvSpPr txBox="1"/>
           <p:nvPr/>
         </p:nvSpPr>
         <p:spPr>
           <a:xfrm>
-            <a:off x="8412480" y="1828800"/>
-            <a:ext cx="2834640" cy="457200"/>
+            <a:off x="914400" y="3474720"/>
+            <a:ext cx="2926080" cy="548640"/>
           </a:xfrm>
           <a:prstGeom prst="rect">
             <a:avLst/>
@@ -5362,29 +5214,74 @@
           <a:lstStyle/>
           <a:p>
             <a:pPr algn="ctr">
-              <a:defRPr sz="4200" b="1">
-                <a:solidFill>
-                  <a:srgbClr val="16A34A"/>
-                </a:solidFill>
-                <a:latin typeface="Calibri"/>
-              </a:defRPr>
-            </a:pPr>
-            <a:r>
-              <a:t>10%</a:t>
-            </a:r>
-          </a:p>
-        </p:txBody>
-      </p:sp>
-      <p:sp>
-        <p:nvSpPr>
-          <p:cNvPr id="9" name="TextBox 8"/>
+              <a:defRPr sz="1400" b="0">
+                <a:solidFill>
+                  <a:srgbClr val="64748B"/>
+                </a:solidFill>
+                <a:latin typeface="Calibri"/>
+              </a:defRPr>
+            </a:pPr>
+            <a:r>
+              <a:t>Clean lab conditions only</a:t>
+            </a:r>
+          </a:p>
+        </p:txBody>
+      </p:sp>
+      <p:sp>
+        <p:nvSpPr>
+          <p:cNvPr id="9" name="Rounded Rectangle 8"/>
+          <p:cNvSpPr/>
+          <p:nvPr/>
+        </p:nvSpPr>
+        <p:spPr>
+          <a:xfrm>
+            <a:off x="4389120" y="2286000"/>
+            <a:ext cx="3291840" cy="2743200"/>
+          </a:xfrm>
+          <a:prstGeom prst="roundRect">
+            <a:avLst/>
+          </a:prstGeom>
+          <a:solidFill>
+            <a:srgbClr val="FFFBEB"/>
+          </a:solidFill>
+          <a:ln w="12700">
+            <a:solidFill>
+              <a:srgbClr val="FDE68A"/>
+            </a:solidFill>
+          </a:ln>
+        </p:spPr>
+        <p:style>
+          <a:lnRef idx="1">
+            <a:schemeClr val="accent1"/>
+          </a:lnRef>
+          <a:fillRef idx="3">
+            <a:schemeClr val="accent1"/>
+          </a:fillRef>
+          <a:effectRef idx="2">
+            <a:schemeClr val="accent1"/>
+          </a:effectRef>
+          <a:fontRef idx="minor">
+            <a:schemeClr val="lt1"/>
+          </a:fontRef>
+        </p:style>
+        <p:txBody>
+          <a:bodyPr rtlCol="0" anchor="ctr"/>
+          <a:lstStyle/>
+          <a:p>
+            <a:pPr algn="ctr"/>
+          </a:p>
+        </p:txBody>
+      </p:sp>
+      <p:sp>
+        <p:nvSpPr>
+          <p:cNvPr id="10" name="TextBox 9"/>
           <p:cNvSpPr txBox="1"/>
           <p:nvPr/>
         </p:nvSpPr>
         <p:spPr>
           <a:xfrm>
-            <a:off x="8412480" y="2286000"/>
-            <a:ext cx="2834640" cy="274320"/>
+            <a:off x="4389120" y="2560320"/>
+            <a:ext cx="3291840" cy="457200"/>
           </a:xfrm>
           <a:prstGeom prst="rect">
             <a:avLst/>
@@ -5398,29 +5295,29 @@
           <a:lstStyle/>
           <a:p>
             <a:pPr algn="ctr">
-              <a:defRPr sz="1600" b="0">
-                <a:solidFill>
-                  <a:srgbClr val="64748B"/>
-                </a:solidFill>
-                <a:latin typeface="Calibri"/>
-              </a:defRPr>
-            </a:pPr>
-            <a:r>
-              <a:t>operational sample</a:t>
-            </a:r>
-          </a:p>
-        </p:txBody>
-      </p:sp>
-      <p:sp>
-        <p:nvSpPr>
-          <p:cNvPr id="10" name="TextBox 9"/>
+              <a:defRPr sz="3600" b="1">
+                <a:solidFill>
+                  <a:srgbClr val="D97706"/>
+                </a:solidFill>
+                <a:latin typeface="Calibri"/>
+              </a:defRPr>
+            </a:pPr>
+            <a:r>
+              <a:t>● Warning</a:t>
+            </a:r>
+          </a:p>
+        </p:txBody>
+      </p:sp>
+      <p:sp>
+        <p:nvSpPr>
+          <p:cNvPr id="11" name="TextBox 10"/>
           <p:cNvSpPr txBox="1"/>
           <p:nvPr/>
         </p:nvSpPr>
         <p:spPr>
           <a:xfrm>
-            <a:off x="8412480" y="2651760"/>
-            <a:ext cx="2834640" cy="274320"/>
+            <a:off x="4389120" y="3108960"/>
+            <a:ext cx="3291840" cy="365760"/>
           </a:xfrm>
           <a:prstGeom prst="rect">
             <a:avLst/>
@@ -5434,29 +5331,29 @@
           <a:lstStyle/>
           <a:p>
             <a:pPr algn="ctr">
-              <a:defRPr sz="1400" b="0">
-                <a:solidFill>
-                  <a:srgbClr val="64748B"/>
-                </a:solidFill>
-                <a:latin typeface="Calibri"/>
-              </a:defRPr>
-            </a:pPr>
-            <a:r>
-              <a:t>at the elbow of</a:t>
-            </a:r>
-          </a:p>
-        </p:txBody>
-      </p:sp>
-      <p:sp>
-        <p:nvSpPr>
-          <p:cNvPr id="11" name="TextBox 10"/>
+              <a:defRPr sz="2200" b="1">
+                <a:solidFill>
+                  <a:srgbClr val="1E293B"/>
+                </a:solidFill>
+                <a:latin typeface="Calibri"/>
+              </a:defRPr>
+            </a:pPr>
+            <a:r>
+              <a:t>ECE 0.05–0.10</a:t>
+            </a:r>
+          </a:p>
+        </p:txBody>
+      </p:sp>
+      <p:sp>
+        <p:nvSpPr>
+          <p:cNvPr id="12" name="TextBox 11"/>
           <p:cNvSpPr txBox="1"/>
           <p:nvPr/>
         </p:nvSpPr>
         <p:spPr>
           <a:xfrm>
-            <a:off x="8412480" y="2926080"/>
-            <a:ext cx="2834640" cy="274320"/>
+            <a:off x="4572000" y="3474720"/>
+            <a:ext cx="2926080" cy="548640"/>
           </a:xfrm>
           <a:prstGeom prst="rect">
             <a:avLst/>
@@ -5478,14 +5375,211 @@
               </a:defRPr>
             </a:pPr>
             <a:r>
-              <a:t>the ECE curve</a:t>
-            </a:r>
-          </a:p>
-        </p:txBody>
-      </p:sp>
-      <p:sp>
-        <p:nvSpPr>
-          <p:cNvPr id="12" name="TextBox 11"/>
+              <a:t>Recalibrated operation</a:t>
+            </a:r>
+            <a:br/>
+            <a:r>
+              <a:t>10% operational sample</a:t>
+            </a:r>
+          </a:p>
+        </p:txBody>
+      </p:sp>
+      <p:sp>
+        <p:nvSpPr>
+          <p:cNvPr id="13" name="Rounded Rectangle 12"/>
+          <p:cNvSpPr/>
+          <p:nvPr/>
+        </p:nvSpPr>
+        <p:spPr>
+          <a:xfrm>
+            <a:off x="8046720" y="2286000"/>
+            <a:ext cx="3291840" cy="2743200"/>
+          </a:xfrm>
+          <a:prstGeom prst="roundRect">
+            <a:avLst/>
+          </a:prstGeom>
+          <a:solidFill>
+            <a:srgbClr val="FEF2F2"/>
+          </a:solidFill>
+          <a:ln w="12700">
+            <a:solidFill>
+              <a:srgbClr val="FECACA"/>
+            </a:solidFill>
+          </a:ln>
+        </p:spPr>
+        <p:style>
+          <a:lnRef idx="1">
+            <a:schemeClr val="accent1"/>
+          </a:lnRef>
+          <a:fillRef idx="3">
+            <a:schemeClr val="accent1"/>
+          </a:fillRef>
+          <a:effectRef idx="2">
+            <a:schemeClr val="accent1"/>
+          </a:effectRef>
+          <a:fontRef idx="minor">
+            <a:schemeClr val="lt1"/>
+          </a:fontRef>
+        </p:style>
+        <p:txBody>
+          <a:bodyPr rtlCol="0" anchor="ctr"/>
+          <a:lstStyle/>
+          <a:p>
+            <a:pPr algn="ctr"/>
+          </a:p>
+        </p:txBody>
+      </p:sp>
+      <p:sp>
+        <p:nvSpPr>
+          <p:cNvPr id="14" name="TextBox 13"/>
+          <p:cNvSpPr txBox="1"/>
+          <p:nvPr/>
+        </p:nvSpPr>
+        <p:spPr>
+          <a:xfrm>
+            <a:off x="8046720" y="2560320"/>
+            <a:ext cx="3291840" cy="457200"/>
+          </a:xfrm>
+          <a:prstGeom prst="rect">
+            <a:avLst/>
+          </a:prstGeom>
+          <a:noFill/>
+        </p:spPr>
+        <p:txBody>
+          <a:bodyPr wrap="square">
+            <a:spAutoFit/>
+          </a:bodyPr>
+          <a:lstStyle/>
+          <a:p>
+            <a:pPr algn="ctr">
+              <a:defRPr sz="3600" b="1">
+                <a:solidFill>
+                  <a:srgbClr val="DC2626"/>
+                </a:solidFill>
+                <a:latin typeface="Calibri"/>
+              </a:defRPr>
+            </a:pPr>
+            <a:r>
+              <a:t>● Unsafe</a:t>
+            </a:r>
+          </a:p>
+        </p:txBody>
+      </p:sp>
+      <p:sp>
+        <p:nvSpPr>
+          <p:cNvPr id="15" name="TextBox 14"/>
+          <p:cNvSpPr txBox="1"/>
+          <p:nvPr/>
+        </p:nvSpPr>
+        <p:spPr>
+          <a:xfrm>
+            <a:off x="8046720" y="3108960"/>
+            <a:ext cx="3291840" cy="365760"/>
+          </a:xfrm>
+          <a:prstGeom prst="rect">
+            <a:avLst/>
+          </a:prstGeom>
+          <a:noFill/>
+        </p:spPr>
+        <p:txBody>
+          <a:bodyPr wrap="square">
+            <a:spAutoFit/>
+          </a:bodyPr>
+          <a:lstStyle/>
+          <a:p>
+            <a:pPr algn="ctr">
+              <a:defRPr sz="2200" b="1">
+                <a:solidFill>
+                  <a:srgbClr val="1E293B"/>
+                </a:solidFill>
+                <a:latin typeface="Calibri"/>
+              </a:defRPr>
+            </a:pPr>
+            <a:r>
+              <a:t>ECE &gt; 0.10</a:t>
+            </a:r>
+          </a:p>
+        </p:txBody>
+      </p:sp>
+      <p:sp>
+        <p:nvSpPr>
+          <p:cNvPr id="16" name="TextBox 15"/>
+          <p:cNvSpPr txBox="1"/>
+          <p:nvPr/>
+        </p:nvSpPr>
+        <p:spPr>
+          <a:xfrm>
+            <a:off x="8229600" y="3474720"/>
+            <a:ext cx="2926080" cy="548640"/>
+          </a:xfrm>
+          <a:prstGeom prst="rect">
+            <a:avLst/>
+          </a:prstGeom>
+          <a:noFill/>
+        </p:spPr>
+        <p:txBody>
+          <a:bodyPr wrap="square">
+            <a:spAutoFit/>
+          </a:bodyPr>
+          <a:lstStyle/>
+          <a:p>
+            <a:pPr algn="ctr">
+              <a:defRPr sz="1400" b="0">
+                <a:solidFill>
+                  <a:srgbClr val="64748B"/>
+                </a:solidFill>
+                <a:latin typeface="Calibri"/>
+              </a:defRPr>
+            </a:pPr>
+            <a:r>
+              <a:t>Direct deployment under</a:t>
+            </a:r>
+            <a:br/>
+            <a:r>
+              <a:t>any partial cycling (ECE &gt; 0.27)</a:t>
+            </a:r>
+          </a:p>
+        </p:txBody>
+      </p:sp>
+      <p:sp>
+        <p:nvSpPr>
+          <p:cNvPr id="17" name="TextBox 16"/>
+          <p:cNvSpPr txBox="1"/>
+          <p:nvPr/>
+        </p:nvSpPr>
+        <p:spPr>
+          <a:xfrm>
+            <a:off x="731520" y="5303520"/>
+            <a:ext cx="10058400" cy="365760"/>
+          </a:xfrm>
+          <a:prstGeom prst="rect">
+            <a:avLst/>
+          </a:prstGeom>
+          <a:noFill/>
+        </p:spPr>
+        <p:txBody>
+          <a:bodyPr wrap="square">
+            <a:spAutoFit/>
+          </a:bodyPr>
+          <a:lstStyle/>
+          <a:p>
+            <a:pPr algn="ctr">
+              <a:defRPr sz="1600" b="0">
+                <a:solidFill>
+                  <a:srgbClr val="64748B"/>
+                </a:solidFill>
+                <a:latin typeface="Calibri"/>
+              </a:defRPr>
+            </a:pPr>
+            <a:r>
+              <a:t>Direct deployment under partial cycling pushes ECE &gt; 0.27 — firmly in the unsafe zone</a:t>
+            </a:r>
+          </a:p>
+        </p:txBody>
+      </p:sp>
+      <p:sp>
+        <p:nvSpPr>
+          <p:cNvPr id="18" name="TextBox 17"/>
           <p:cNvSpPr txBox="1"/>
           <p:nvPr/>
         </p:nvSpPr>
@@ -5514,7 +5608,7 @@
               </a:defRPr>
             </a:pPr>
             <a:r>
-              <a:t>13 / 14</a:t>
+              <a:t>13 / 15</a:t>
             </a:r>
           </a:p>
         </p:txBody>
@@ -5528,6 +5622,492 @@
 </file>
 
 <file path=ppt/slides/slide14.xml><?xml version="1.0" encoding="utf-8"?>
+<p:sld xmlns:a="http://schemas.openxmlformats.org/drawingml/2006/main" xmlns:p="http://schemas.openxmlformats.org/presentationml/2006/main" xmlns:r="http://schemas.openxmlformats.org/officeDocument/2006/relationships">
+  <p:cSld>
+    <p:bg>
+      <p:bgPr>
+        <a:solidFill>
+          <a:srgbClr val="F8FAFC"/>
+        </a:solidFill>
+        <a:effectLst/>
+      </p:bgPr>
+    </p:bg>
+    <p:spTree>
+      <p:nvGrpSpPr>
+        <p:cNvPr id="1" name=""/>
+        <p:cNvGrpSpPr/>
+        <p:nvPr/>
+      </p:nvGrpSpPr>
+      <p:grpSpPr/>
+      <p:sp>
+        <p:nvSpPr>
+          <p:cNvPr id="2" name="Rectangle 1"/>
+          <p:cNvSpPr/>
+          <p:nvPr/>
+        </p:nvSpPr>
+        <p:spPr>
+          <a:xfrm>
+            <a:off x="0" y="6818000"/>
+            <a:ext cx="12192000" cy="40000"/>
+          </a:xfrm>
+          <a:prstGeom prst="rect">
+            <a:avLst/>
+          </a:prstGeom>
+          <a:solidFill>
+            <a:srgbClr val="F59E0B"/>
+          </a:solidFill>
+          <a:ln>
+            <a:noFill/>
+          </a:ln>
+        </p:spPr>
+        <p:style>
+          <a:lnRef idx="1">
+            <a:schemeClr val="accent1"/>
+          </a:lnRef>
+          <a:fillRef idx="3">
+            <a:schemeClr val="accent1"/>
+          </a:fillRef>
+          <a:effectRef idx="2">
+            <a:schemeClr val="accent1"/>
+          </a:effectRef>
+          <a:fontRef idx="minor">
+            <a:schemeClr val="lt1"/>
+          </a:fontRef>
+        </p:style>
+        <p:txBody>
+          <a:bodyPr rtlCol="0" anchor="ctr"/>
+          <a:lstStyle/>
+          <a:p>
+            <a:pPr algn="ctr"/>
+          </a:p>
+        </p:txBody>
+      </p:sp>
+      <p:sp>
+        <p:nvSpPr>
+          <p:cNvPr id="3" name="TextBox 2"/>
+          <p:cNvSpPr txBox="1"/>
+          <p:nvPr/>
+        </p:nvSpPr>
+        <p:spPr>
+          <a:xfrm>
+            <a:off x="731520" y="365760"/>
+            <a:ext cx="3657600" cy="274320"/>
+          </a:xfrm>
+          <a:prstGeom prst="rect">
+            <a:avLst/>
+          </a:prstGeom>
+          <a:noFill/>
+        </p:spPr>
+        <p:txBody>
+          <a:bodyPr wrap="square">
+            <a:spAutoFit/>
+          </a:bodyPr>
+          <a:lstStyle/>
+          <a:p>
+            <a:pPr algn="l">
+              <a:defRPr sz="1100" b="1">
+                <a:solidFill>
+                  <a:srgbClr val="F59E0B"/>
+                </a:solidFill>
+                <a:latin typeface="Calibri"/>
+              </a:defRPr>
+            </a:pPr>
+            <a:r>
+              <a:t>ACTION</a:t>
+            </a:r>
+          </a:p>
+        </p:txBody>
+      </p:sp>
+      <p:sp>
+        <p:nvSpPr>
+          <p:cNvPr id="4" name="TextBox 3"/>
+          <p:cNvSpPr txBox="1"/>
+          <p:nvPr/>
+        </p:nvSpPr>
+        <p:spPr>
+          <a:xfrm>
+            <a:off x="731520" y="640080"/>
+            <a:ext cx="9144000" cy="548640"/>
+          </a:xfrm>
+          <a:prstGeom prst="rect">
+            <a:avLst/>
+          </a:prstGeom>
+          <a:noFill/>
+        </p:spPr>
+        <p:txBody>
+          <a:bodyPr wrap="square">
+            <a:spAutoFit/>
+          </a:bodyPr>
+          <a:lstStyle/>
+          <a:p>
+            <a:pPr algn="l">
+              <a:defRPr sz="3600" b="1">
+                <a:solidFill>
+                  <a:srgbClr val="0F172A"/>
+                </a:solidFill>
+                <a:latin typeface="Calibri"/>
+              </a:defRPr>
+            </a:pPr>
+            <a:r>
+              <a:t>Practical deployment path</a:t>
+            </a:r>
+          </a:p>
+        </p:txBody>
+      </p:sp>
+      <p:sp>
+        <p:nvSpPr>
+          <p:cNvPr id="5" name="TextBox 4"/>
+          <p:cNvSpPr txBox="1"/>
+          <p:nvPr/>
+        </p:nvSpPr>
+        <p:spPr>
+          <a:xfrm>
+            <a:off x="731520" y="1463040"/>
+            <a:ext cx="6858000" cy="2743200"/>
+          </a:xfrm>
+          <a:prstGeom prst="rect">
+            <a:avLst/>
+          </a:prstGeom>
+          <a:noFill/>
+        </p:spPr>
+        <p:txBody>
+          <a:bodyPr wrap="square">
+            <a:spAutoFit/>
+          </a:bodyPr>
+          <a:lstStyle/>
+          <a:p>
+            <a:pPr algn="l">
+              <a:defRPr sz="2000" b="0">
+                <a:solidFill>
+                  <a:srgbClr val="1E293B"/>
+                </a:solidFill>
+                <a:latin typeface="Calibri"/>
+              </a:defRPr>
+            </a:pPr>
+            <a:r>
+              <a:t>1. Deploy the frozen XGBoost model as-is</a:t>
+            </a:r>
+          </a:p>
+          <a:p>
+            <a:pPr algn="l">
+              <a:spcBef>
+                <a:spcPts val="1000"/>
+              </a:spcBef>
+              <a:defRPr sz="2000" b="0">
+                <a:solidFill>
+                  <a:srgbClr val="1E293B"/>
+                </a:solidFill>
+                <a:latin typeface="Calibri"/>
+              </a:defRPr>
+            </a:pPr>
+            <a:r>
+              <a:t>2. Collect 50–100 operational cycles from normal BESS operation</a:t>
+            </a:r>
+          </a:p>
+          <a:p>
+            <a:pPr algn="l">
+              <a:spcBef>
+                <a:spcPts val="1000"/>
+              </a:spcBef>
+              <a:defRPr sz="2000" b="0">
+                <a:solidFill>
+                  <a:srgbClr val="1E293B"/>
+                </a:solidFill>
+                <a:latin typeface="Calibri"/>
+              </a:defRPr>
+            </a:pPr>
+            <a:r>
+              <a:t>3. Fit a new isotonic regression on these cycles</a:t>
+            </a:r>
+          </a:p>
+          <a:p>
+            <a:pPr algn="l">
+              <a:spcBef>
+                <a:spcPts val="1000"/>
+              </a:spcBef>
+              <a:defRPr sz="2000" b="0">
+                <a:solidFill>
+                  <a:srgbClr val="1E293B"/>
+                </a:solidFill>
+                <a:latin typeface="Calibri"/>
+              </a:defRPr>
+            </a:pPr>
+            <a:r>
+              <a:t>4. Deploy the recalibrated model — no base classifier retraining needed</a:t>
+            </a:r>
+          </a:p>
+        </p:txBody>
+      </p:sp>
+      <p:sp>
+        <p:nvSpPr>
+          <p:cNvPr id="6" name="TextBox 5"/>
+          <p:cNvSpPr txBox="1"/>
+          <p:nvPr/>
+        </p:nvSpPr>
+        <p:spPr>
+          <a:xfrm>
+            <a:off x="731520" y="4389120"/>
+            <a:ext cx="6858000" cy="365760"/>
+          </a:xfrm>
+          <a:prstGeom prst="rect">
+            <a:avLst/>
+          </a:prstGeom>
+          <a:noFill/>
+        </p:spPr>
+        <p:txBody>
+          <a:bodyPr wrap="square">
+            <a:spAutoFit/>
+          </a:bodyPr>
+          <a:lstStyle/>
+          <a:p>
+            <a:pPr algn="l">
+              <a:defRPr sz="1400" b="0">
+                <a:solidFill>
+                  <a:srgbClr val="64748B"/>
+                </a:solidFill>
+                <a:latin typeface="Calibri"/>
+              </a:defRPr>
+            </a:pPr>
+            <a:r>
+              <a:t>No original training data required · No additional feature engineering</a:t>
+            </a:r>
+          </a:p>
+        </p:txBody>
+      </p:sp>
+      <p:sp>
+        <p:nvSpPr>
+          <p:cNvPr id="7" name="Rounded Rectangle 6"/>
+          <p:cNvSpPr/>
+          <p:nvPr/>
+        </p:nvSpPr>
+        <p:spPr>
+          <a:xfrm>
+            <a:off x="8229600" y="1828800"/>
+            <a:ext cx="3200400" cy="1828800"/>
+          </a:xfrm>
+          <a:prstGeom prst="roundRect">
+            <a:avLst/>
+          </a:prstGeom>
+          <a:solidFill>
+            <a:srgbClr val="FFFFFF"/>
+          </a:solidFill>
+          <a:ln w="12700">
+            <a:solidFill>
+              <a:srgbClr val="E2E8F0"/>
+            </a:solidFill>
+          </a:ln>
+        </p:spPr>
+        <p:style>
+          <a:lnRef idx="1">
+            <a:schemeClr val="accent1"/>
+          </a:lnRef>
+          <a:fillRef idx="3">
+            <a:schemeClr val="accent1"/>
+          </a:fillRef>
+          <a:effectRef idx="2">
+            <a:schemeClr val="accent1"/>
+          </a:effectRef>
+          <a:fontRef idx="minor">
+            <a:schemeClr val="lt1"/>
+          </a:fontRef>
+        </p:style>
+        <p:txBody>
+          <a:bodyPr rtlCol="0" anchor="ctr"/>
+          <a:lstStyle/>
+          <a:p>
+            <a:pPr algn="ctr"/>
+          </a:p>
+        </p:txBody>
+      </p:sp>
+      <p:sp>
+        <p:nvSpPr>
+          <p:cNvPr id="8" name="TextBox 7"/>
+          <p:cNvSpPr txBox="1"/>
+          <p:nvPr/>
+        </p:nvSpPr>
+        <p:spPr>
+          <a:xfrm>
+            <a:off x="8412480" y="1828800"/>
+            <a:ext cx="2834640" cy="457200"/>
+          </a:xfrm>
+          <a:prstGeom prst="rect">
+            <a:avLst/>
+          </a:prstGeom>
+          <a:noFill/>
+        </p:spPr>
+        <p:txBody>
+          <a:bodyPr wrap="square">
+            <a:spAutoFit/>
+          </a:bodyPr>
+          <a:lstStyle/>
+          <a:p>
+            <a:pPr algn="ctr">
+              <a:defRPr sz="4200" b="1">
+                <a:solidFill>
+                  <a:srgbClr val="16A34A"/>
+                </a:solidFill>
+                <a:latin typeface="Calibri"/>
+              </a:defRPr>
+            </a:pPr>
+            <a:r>
+              <a:t>10%</a:t>
+            </a:r>
+          </a:p>
+        </p:txBody>
+      </p:sp>
+      <p:sp>
+        <p:nvSpPr>
+          <p:cNvPr id="9" name="TextBox 8"/>
+          <p:cNvSpPr txBox="1"/>
+          <p:nvPr/>
+        </p:nvSpPr>
+        <p:spPr>
+          <a:xfrm>
+            <a:off x="8412480" y="2286000"/>
+            <a:ext cx="2834640" cy="274320"/>
+          </a:xfrm>
+          <a:prstGeom prst="rect">
+            <a:avLst/>
+          </a:prstGeom>
+          <a:noFill/>
+        </p:spPr>
+        <p:txBody>
+          <a:bodyPr wrap="square">
+            <a:spAutoFit/>
+          </a:bodyPr>
+          <a:lstStyle/>
+          <a:p>
+            <a:pPr algn="ctr">
+              <a:defRPr sz="1600" b="0">
+                <a:solidFill>
+                  <a:srgbClr val="64748B"/>
+                </a:solidFill>
+                <a:latin typeface="Calibri"/>
+              </a:defRPr>
+            </a:pPr>
+            <a:r>
+              <a:t>operational sample</a:t>
+            </a:r>
+          </a:p>
+        </p:txBody>
+      </p:sp>
+      <p:sp>
+        <p:nvSpPr>
+          <p:cNvPr id="10" name="TextBox 9"/>
+          <p:cNvSpPr txBox="1"/>
+          <p:nvPr/>
+        </p:nvSpPr>
+        <p:spPr>
+          <a:xfrm>
+            <a:off x="8412480" y="2651760"/>
+            <a:ext cx="2834640" cy="274320"/>
+          </a:xfrm>
+          <a:prstGeom prst="rect">
+            <a:avLst/>
+          </a:prstGeom>
+          <a:noFill/>
+        </p:spPr>
+        <p:txBody>
+          <a:bodyPr wrap="square">
+            <a:spAutoFit/>
+          </a:bodyPr>
+          <a:lstStyle/>
+          <a:p>
+            <a:pPr algn="ctr">
+              <a:defRPr sz="1400" b="0">
+                <a:solidFill>
+                  <a:srgbClr val="64748B"/>
+                </a:solidFill>
+                <a:latin typeface="Calibri"/>
+              </a:defRPr>
+            </a:pPr>
+            <a:r>
+              <a:t>at the elbow of</a:t>
+            </a:r>
+          </a:p>
+        </p:txBody>
+      </p:sp>
+      <p:sp>
+        <p:nvSpPr>
+          <p:cNvPr id="11" name="TextBox 10"/>
+          <p:cNvSpPr txBox="1"/>
+          <p:nvPr/>
+        </p:nvSpPr>
+        <p:spPr>
+          <a:xfrm>
+            <a:off x="8412480" y="2926080"/>
+            <a:ext cx="2834640" cy="274320"/>
+          </a:xfrm>
+          <a:prstGeom prst="rect">
+            <a:avLst/>
+          </a:prstGeom>
+          <a:noFill/>
+        </p:spPr>
+        <p:txBody>
+          <a:bodyPr wrap="square">
+            <a:spAutoFit/>
+          </a:bodyPr>
+          <a:lstStyle/>
+          <a:p>
+            <a:pPr algn="ctr">
+              <a:defRPr sz="1400" b="0">
+                <a:solidFill>
+                  <a:srgbClr val="64748B"/>
+                </a:solidFill>
+                <a:latin typeface="Calibri"/>
+              </a:defRPr>
+            </a:pPr>
+            <a:r>
+              <a:t>the ECE curve</a:t>
+            </a:r>
+          </a:p>
+        </p:txBody>
+      </p:sp>
+      <p:sp>
+        <p:nvSpPr>
+          <p:cNvPr id="12" name="TextBox 11"/>
+          <p:cNvSpPr txBox="1"/>
+          <p:nvPr/>
+        </p:nvSpPr>
+        <p:spPr>
+          <a:xfrm>
+            <a:off x="10241280" y="6400800"/>
+            <a:ext cx="1371600" cy="274320"/>
+          </a:xfrm>
+          <a:prstGeom prst="rect">
+            <a:avLst/>
+          </a:prstGeom>
+          <a:noFill/>
+        </p:spPr>
+        <p:txBody>
+          <a:bodyPr wrap="square">
+            <a:spAutoFit/>
+          </a:bodyPr>
+          <a:lstStyle/>
+          <a:p>
+            <a:pPr algn="r">
+              <a:defRPr sz="1000" b="0">
+                <a:solidFill>
+                  <a:srgbClr val="64748B"/>
+                </a:solidFill>
+                <a:latin typeface="Calibri"/>
+              </a:defRPr>
+            </a:pPr>
+            <a:r>
+              <a:t>14 / 15</a:t>
+            </a:r>
+          </a:p>
+        </p:txBody>
+      </p:sp>
+    </p:spTree>
+  </p:cSld>
+  <p:clrMapOvr>
+    <a:masterClrMapping/>
+  </p:clrMapOvr>
+</p:sld>
+</file>
+
+<file path=ppt/slides/slide15.xml><?xml version="1.0" encoding="utf-8"?>
 <p:sld xmlns:a="http://schemas.openxmlformats.org/drawingml/2006/main" xmlns:p="http://schemas.openxmlformats.org/presentationml/2006/main" xmlns:r="http://schemas.openxmlformats.org/officeDocument/2006/relationships">
   <p:cSld>
     <p:bg>
@@ -5775,7 +6355,7 @@
               </a:defRPr>
             </a:pPr>
             <a:r>
-              <a:t>14 / 14</a:t>
+              <a:t>15 / 15</a:t>
             </a:r>
           </a:p>
         </p:txBody>
@@ -6177,7 +6757,7 @@
               </a:defRPr>
             </a:pPr>
             <a:r>
-              <a:t>2 / 14</a:t>
+              <a:t>2 / 15</a:t>
             </a:r>
           </a:p>
         </p:txBody>
@@ -6398,7 +6978,7 @@
               </a:defRPr>
             </a:pPr>
             <a:r>
-              <a:t>3 / 14</a:t>
+              <a:t>3 / 15</a:t>
             </a:r>
           </a:p>
         </p:txBody>
@@ -7008,7 +7588,7 @@
               </a:defRPr>
             </a:pPr>
             <a:r>
-              <a:t>4 / 14</a:t>
+              <a:t>4 / 15</a:t>
             </a:r>
           </a:p>
         </p:txBody>
@@ -7865,7 +8445,7 @@
               </a:defRPr>
             </a:pPr>
             <a:r>
-              <a:t>5 / 14</a:t>
+              <a:t>5 / 15</a:t>
             </a:r>
           </a:p>
         </p:txBody>
@@ -8372,7 +8952,7 @@
               </a:defRPr>
             </a:pPr>
             <a:r>
-              <a:t>6 / 14</a:t>
+              <a:t>6 / 15</a:t>
             </a:r>
           </a:p>
         </p:txBody>
@@ -8609,7 +9189,7 @@
               </a:defRPr>
             </a:pPr>
             <a:r>
-              <a:t>7 / 14</a:t>
+              <a:t>7 / 15</a:t>
             </a:r>
           </a:p>
         </p:txBody>
@@ -8810,7 +9390,7 @@
               </a:defRPr>
             </a:pPr>
             <a:r>
-              <a:t>8 / 14</a:t>
+              <a:t>8 / 15</a:t>
             </a:r>
           </a:p>
         </p:txBody>
@@ -9031,7 +9611,7 @@
               </a:defRPr>
             </a:pPr>
             <a:r>
-              <a:t>9 / 14</a:t>
+              <a:t>9 / 15</a:t>
             </a:r>
           </a:p>
         </p:txBody>

</xml_diff>

<commit_message>
Fix pptx layout: card labels, slide 10 overlap, slide 12 overlap, figure padding, distribution annotation
</commit_message>
<xml_diff>
--- a/opendesign/mockups/conference-b-deck/robustness_presentation.pptx
+++ b/opendesign/mockups/conference-b-deck/robustness_presentation.pptx
@@ -3418,8 +3418,8 @@
         </p:nvSpPr>
         <p:spPr>
           <a:xfrm>
-            <a:off x="731520" y="640080"/>
-            <a:ext cx="7315200" cy="457200"/>
+            <a:off x="731520" y="548640"/>
+            <a:ext cx="7315200" cy="640080"/>
           </a:xfrm>
           <a:prstGeom prst="rect">
             <a:avLst/>
@@ -3454,8 +3454,8 @@
         </p:nvSpPr>
         <p:spPr>
           <a:xfrm>
-            <a:off x="731520" y="1188720"/>
-            <a:ext cx="4754880" cy="365760"/>
+            <a:off x="731520" y="1463040"/>
+            <a:ext cx="4754880" cy="457200"/>
           </a:xfrm>
           <a:prstGeom prst="rect">
             <a:avLst/>
@@ -3477,7 +3477,7 @@
               </a:defRPr>
             </a:pPr>
             <a:r>
-              <a:t>Both isotonic and Platt recalibration recover calibration. Mean±std across 5 seeds × 4 severities:</a:t>
+              <a:t>All three recalibration methods recover calibration on held-out data. Mean±std across 5 seeds × 4 severities:</a:t>
             </a:r>
           </a:p>
         </p:txBody>
@@ -4175,7 +4175,7 @@
         <p:spPr>
           <a:xfrm>
             <a:off x="6858000" y="914400"/>
-            <a:ext cx="4572000" cy="3740727"/>
+            <a:ext cx="4572000" cy="3768227"/>
           </a:xfrm>
           <a:prstGeom prst="rect">
             <a:avLst/>
@@ -4376,7 +4376,7 @@
         <p:spPr>
           <a:xfrm>
             <a:off x="914400" y="1280160"/>
-            <a:ext cx="7315200" cy="4876800"/>
+            <a:ext cx="7315200" cy="4821382"/>
           </a:xfrm>
           <a:prstGeom prst="rect">
             <a:avLst/>
@@ -4568,8 +4568,8 @@
         </p:nvSpPr>
         <p:spPr>
           <a:xfrm>
-            <a:off x="731520" y="640080"/>
-            <a:ext cx="9144000" cy="548640"/>
+            <a:off x="731520" y="457200"/>
+            <a:ext cx="9144000" cy="731520"/>
           </a:xfrm>
           <a:prstGeom prst="rect">
             <a:avLst/>
@@ -4583,7 +4583,7 @@
           <a:lstStyle/>
           <a:p>
             <a:pPr algn="l">
-              <a:defRPr sz="3600" b="1">
+              <a:defRPr sz="3200" b="1">
                 <a:solidFill>
                   <a:srgbClr val="0F172A"/>
                 </a:solidFill>
@@ -4604,7 +4604,7 @@
         </p:nvSpPr>
         <p:spPr>
           <a:xfrm>
-            <a:off x="731520" y="1188720"/>
+            <a:off x="731520" y="1828800"/>
             <a:ext cx="5486400" cy="365760"/>
           </a:xfrm>
           <a:prstGeom prst="rect">
@@ -4648,7 +4648,7 @@
         </p:blipFill>
         <p:spPr>
           <a:xfrm>
-            <a:off x="457200" y="1737360"/>
+            <a:off x="457200" y="2468880"/>
             <a:ext cx="6858000" cy="3086100"/>
           </a:xfrm>
           <a:prstGeom prst="rect">
@@ -4664,7 +4664,7 @@
         </p:nvSpPr>
         <p:spPr>
           <a:xfrm>
-            <a:off x="457200" y="5852160"/>
+            <a:off x="457200" y="5669280"/>
             <a:ext cx="6858000" cy="365760"/>
           </a:xfrm>
           <a:prstGeom prst="rect">
@@ -4679,7 +4679,7 @@
           <a:lstStyle/>
           <a:p>
             <a:pPr algn="ctr">
-              <a:defRPr sz="1300" b="0">
+              <a:defRPr sz="1400" b="0">
                 <a:solidFill>
                   <a:srgbClr val="64748B"/>
                 </a:solidFill>
@@ -5883,7 +5883,7 @@
         <p:spPr>
           <a:xfrm>
             <a:off x="8229600" y="1828800"/>
-            <a:ext cx="3200400" cy="1828800"/>
+            <a:ext cx="3200400" cy="2286000"/>
           </a:xfrm>
           <a:prstGeom prst="roundRect">
             <a:avLst/>
@@ -5927,8 +5927,8 @@
         </p:nvSpPr>
         <p:spPr>
           <a:xfrm>
-            <a:off x="8412480" y="1828800"/>
-            <a:ext cx="2834640" cy="457200"/>
+            <a:off x="8412480" y="1920240"/>
+            <a:ext cx="2834640" cy="548640"/>
           </a:xfrm>
           <a:prstGeom prst="rect">
             <a:avLst/>
@@ -5963,8 +5963,8 @@
         </p:nvSpPr>
         <p:spPr>
           <a:xfrm>
-            <a:off x="8412480" y="2286000"/>
-            <a:ext cx="2834640" cy="274320"/>
+            <a:off x="8412480" y="2468880"/>
+            <a:ext cx="2834640" cy="457200"/>
           </a:xfrm>
           <a:prstGeom prst="rect">
             <a:avLst/>
@@ -5999,8 +5999,8 @@
         </p:nvSpPr>
         <p:spPr>
           <a:xfrm>
-            <a:off x="8412480" y="2651760"/>
-            <a:ext cx="2834640" cy="274320"/>
+            <a:off x="8412480" y="2926080"/>
+            <a:ext cx="2834640" cy="365760"/>
           </a:xfrm>
           <a:prstGeom prst="rect">
             <a:avLst/>
@@ -6035,8 +6035,8 @@
         </p:nvSpPr>
         <p:spPr>
           <a:xfrm>
-            <a:off x="8412480" y="2926080"/>
-            <a:ext cx="2834640" cy="274320"/>
+            <a:off x="8412480" y="3200400"/>
+            <a:ext cx="2834640" cy="365760"/>
           </a:xfrm>
           <a:prstGeom prst="rect">
             <a:avLst/>
@@ -6473,7 +6473,7 @@
         </p:nvSpPr>
         <p:spPr>
           <a:xfrm>
-            <a:off x="731520" y="640080"/>
+            <a:off x="1097280" y="640080"/>
             <a:ext cx="7315200" cy="548640"/>
           </a:xfrm>
           <a:prstGeom prst="rect">
@@ -6509,8 +6509,8 @@
         </p:nvSpPr>
         <p:spPr>
           <a:xfrm>
-            <a:off x="731520" y="1371600"/>
-            <a:ext cx="5029200" cy="457200"/>
+            <a:off x="1097280" y="1463040"/>
+            <a:ext cx="5029200" cy="548640"/>
           </a:xfrm>
           <a:prstGeom prst="rect">
             <a:avLst/>
@@ -6545,7 +6545,7 @@
         </p:nvSpPr>
         <p:spPr>
           <a:xfrm>
-            <a:off x="731520" y="2011680"/>
+            <a:off x="1097280" y="2194560"/>
             <a:ext cx="5029200" cy="365760"/>
           </a:xfrm>
           <a:prstGeom prst="rect">
@@ -6581,7 +6581,7 @@
         </p:nvSpPr>
         <p:spPr>
           <a:xfrm>
-            <a:off x="731520" y="2560320"/>
+            <a:off x="1097280" y="2743200"/>
             <a:ext cx="5029200" cy="2286000"/>
           </a:xfrm>
           <a:prstGeom prst="rect">
@@ -7550,7 +7550,7 @@
         <p:spPr>
           <a:xfrm>
             <a:off x="5943600" y="1097280"/>
-            <a:ext cx="5303520" cy="3535680"/>
+            <a:ext cx="5303520" cy="3499478"/>
           </a:xfrm>
           <a:prstGeom prst="rect">
             <a:avLst/>
@@ -7742,8 +7742,8 @@
         </p:nvSpPr>
         <p:spPr>
           <a:xfrm>
-            <a:off x="731520" y="1371600"/>
-            <a:ext cx="2560320" cy="1463040"/>
+            <a:off x="731520" y="731520"/>
+            <a:ext cx="2560320" cy="2377440"/>
           </a:xfrm>
           <a:prstGeom prst="roundRect">
             <a:avLst/>
@@ -7787,8 +7787,8 @@
         </p:nvSpPr>
         <p:spPr>
           <a:xfrm>
-            <a:off x="771520" y="1391600"/>
-            <a:ext cx="2480320" cy="640080"/>
+            <a:off x="771520" y="914400"/>
+            <a:ext cx="2480320" cy="1280160"/>
           </a:xfrm>
           <a:prstGeom prst="rect">
             <a:avLst/>
@@ -7823,8 +7823,8 @@
         </p:nvSpPr>
         <p:spPr>
           <a:xfrm>
-            <a:off x="771520" y="2749640"/>
-            <a:ext cx="2480320" cy="320040"/>
+            <a:off x="771520" y="2286000"/>
+            <a:ext cx="2480320" cy="457200"/>
           </a:xfrm>
           <a:prstGeom prst="rect">
             <a:avLst/>
@@ -7859,7 +7859,7 @@
         </p:nvSpPr>
         <p:spPr>
           <a:xfrm>
-            <a:off x="771520" y="2784640"/>
+            <a:off x="771520" y="2697480"/>
             <a:ext cx="2480320" cy="228600"/>
           </a:xfrm>
           <a:prstGeom prst="rect">
@@ -7895,8 +7895,8 @@
         </p:nvSpPr>
         <p:spPr>
           <a:xfrm>
-            <a:off x="3474720" y="1371600"/>
-            <a:ext cx="2560320" cy="1463040"/>
+            <a:off x="3474720" y="731520"/>
+            <a:ext cx="2560320" cy="2377440"/>
           </a:xfrm>
           <a:prstGeom prst="roundRect">
             <a:avLst/>
@@ -7940,8 +7940,8 @@
         </p:nvSpPr>
         <p:spPr>
           <a:xfrm>
-            <a:off x="3514720" y="1391600"/>
-            <a:ext cx="2480320" cy="640080"/>
+            <a:off x="3514720" y="914400"/>
+            <a:ext cx="2480320" cy="1280160"/>
           </a:xfrm>
           <a:prstGeom prst="rect">
             <a:avLst/>
@@ -7976,8 +7976,8 @@
         </p:nvSpPr>
         <p:spPr>
           <a:xfrm>
-            <a:off x="3514720" y="2749640"/>
-            <a:ext cx="2480320" cy="320040"/>
+            <a:off x="3514720" y="2286000"/>
+            <a:ext cx="2480320" cy="457200"/>
           </a:xfrm>
           <a:prstGeom prst="rect">
             <a:avLst/>
@@ -8012,7 +8012,7 @@
         </p:nvSpPr>
         <p:spPr>
           <a:xfrm>
-            <a:off x="3514720" y="2784640"/>
+            <a:off x="3514720" y="2697480"/>
             <a:ext cx="2480320" cy="228600"/>
           </a:xfrm>
           <a:prstGeom prst="rect">
@@ -8048,8 +8048,8 @@
         </p:nvSpPr>
         <p:spPr>
           <a:xfrm>
-            <a:off x="6217920" y="1371600"/>
-            <a:ext cx="2560320" cy="1463040"/>
+            <a:off x="6217920" y="731520"/>
+            <a:ext cx="2560320" cy="2377440"/>
           </a:xfrm>
           <a:prstGeom prst="roundRect">
             <a:avLst/>
@@ -8093,8 +8093,8 @@
         </p:nvSpPr>
         <p:spPr>
           <a:xfrm>
-            <a:off x="6257920" y="1391600"/>
-            <a:ext cx="2480320" cy="640080"/>
+            <a:off x="6257920" y="914400"/>
+            <a:ext cx="2480320" cy="1280160"/>
           </a:xfrm>
           <a:prstGeom prst="rect">
             <a:avLst/>
@@ -8129,8 +8129,8 @@
         </p:nvSpPr>
         <p:spPr>
           <a:xfrm>
-            <a:off x="6257920" y="2749640"/>
-            <a:ext cx="2480320" cy="320040"/>
+            <a:off x="6257920" y="2286000"/>
+            <a:ext cx="2480320" cy="457200"/>
           </a:xfrm>
           <a:prstGeom prst="rect">
             <a:avLst/>
@@ -8165,7 +8165,7 @@
         </p:nvSpPr>
         <p:spPr>
           <a:xfrm>
-            <a:off x="6257920" y="2784640"/>
+            <a:off x="6257920" y="2697480"/>
             <a:ext cx="2480320" cy="228600"/>
           </a:xfrm>
           <a:prstGeom prst="rect">
@@ -8201,8 +8201,8 @@
         </p:nvSpPr>
         <p:spPr>
           <a:xfrm>
-            <a:off x="8961120" y="1371600"/>
-            <a:ext cx="2560320" cy="1463040"/>
+            <a:off x="8961120" y="731520"/>
+            <a:ext cx="2560320" cy="2377440"/>
           </a:xfrm>
           <a:prstGeom prst="roundRect">
             <a:avLst/>
@@ -8246,8 +8246,8 @@
         </p:nvSpPr>
         <p:spPr>
           <a:xfrm>
-            <a:off x="9001120" y="1391600"/>
-            <a:ext cx="2480320" cy="640080"/>
+            <a:off x="9001120" y="914400"/>
+            <a:ext cx="2480320" cy="1280160"/>
           </a:xfrm>
           <a:prstGeom prst="rect">
             <a:avLst/>
@@ -8282,8 +8282,8 @@
         </p:nvSpPr>
         <p:spPr>
           <a:xfrm>
-            <a:off x="9001120" y="2749640"/>
-            <a:ext cx="2480320" cy="320040"/>
+            <a:off x="9001120" y="2286000"/>
+            <a:ext cx="2480320" cy="457200"/>
           </a:xfrm>
           <a:prstGeom prst="rect">
             <a:avLst/>
@@ -8318,7 +8318,7 @@
         </p:nvSpPr>
         <p:spPr>
           <a:xfrm>
-            <a:off x="9001120" y="2784640"/>
+            <a:off x="9001120" y="2697480"/>
             <a:ext cx="2480320" cy="228600"/>
           </a:xfrm>
           <a:prstGeom prst="rect">
@@ -8354,7 +8354,7 @@
         </p:nvSpPr>
         <p:spPr>
           <a:xfrm>
-            <a:off x="731520" y="3200400"/>
+            <a:off x="731520" y="3291840"/>
             <a:ext cx="10058400" cy="2743200"/>
           </a:xfrm>
           <a:prstGeom prst="rect">
@@ -8635,8 +8635,8 @@
         </p:nvSpPr>
         <p:spPr>
           <a:xfrm>
-            <a:off x="731520" y="2011680"/>
-            <a:ext cx="2194560" cy="1280160"/>
+            <a:off x="731520" y="1828800"/>
+            <a:ext cx="2194560" cy="1645920"/>
           </a:xfrm>
           <a:prstGeom prst="roundRect">
             <a:avLst/>
@@ -8680,8 +8680,8 @@
         </p:nvSpPr>
         <p:spPr>
           <a:xfrm>
-            <a:off x="771520" y="2031680"/>
-            <a:ext cx="2114560" cy="640080"/>
+            <a:off x="771520" y="1920240"/>
+            <a:ext cx="2114560" cy="731520"/>
           </a:xfrm>
           <a:prstGeom prst="rect">
             <a:avLst/>
@@ -8716,8 +8716,8 @@
         </p:nvSpPr>
         <p:spPr>
           <a:xfrm>
-            <a:off x="771520" y="3206840"/>
-            <a:ext cx="2114560" cy="320040"/>
+            <a:off x="771520" y="2651760"/>
+            <a:ext cx="2114560" cy="457200"/>
           </a:xfrm>
           <a:prstGeom prst="rect">
             <a:avLst/>
@@ -8752,8 +8752,8 @@
         </p:nvSpPr>
         <p:spPr>
           <a:xfrm>
-            <a:off x="3200400" y="2011680"/>
-            <a:ext cx="2194560" cy="1280160"/>
+            <a:off x="3200400" y="1828800"/>
+            <a:ext cx="2194560" cy="1645920"/>
           </a:xfrm>
           <a:prstGeom prst="roundRect">
             <a:avLst/>
@@ -8797,8 +8797,8 @@
         </p:nvSpPr>
         <p:spPr>
           <a:xfrm>
-            <a:off x="3240400" y="2031680"/>
-            <a:ext cx="2114560" cy="640080"/>
+            <a:off x="3240400" y="1920240"/>
+            <a:ext cx="2114560" cy="731520"/>
           </a:xfrm>
           <a:prstGeom prst="rect">
             <a:avLst/>
@@ -8833,8 +8833,8 @@
         </p:nvSpPr>
         <p:spPr>
           <a:xfrm>
-            <a:off x="3240400" y="3206840"/>
-            <a:ext cx="2114560" cy="320040"/>
+            <a:off x="3240400" y="2651760"/>
+            <a:ext cx="2114560" cy="457200"/>
           </a:xfrm>
           <a:prstGeom prst="rect">
             <a:avLst/>
@@ -8869,7 +8869,7 @@
         </p:nvSpPr>
         <p:spPr>
           <a:xfrm>
-            <a:off x="731520" y="3566160"/>
+            <a:off x="731520" y="3749039"/>
             <a:ext cx="5029200" cy="731520"/>
           </a:xfrm>
           <a:prstGeom prst="rect">
@@ -8914,7 +8914,7 @@
         <p:spPr>
           <a:xfrm>
             <a:off x="5943600" y="1097280"/>
-            <a:ext cx="5303520" cy="4640580"/>
+            <a:ext cx="5303520" cy="4629344"/>
           </a:xfrm>
           <a:prstGeom prst="rect">
             <a:avLst/>

</xml_diff>

<commit_message>
Fix temperature scaling NLL bug: fit T on cal subset only, not full data; update paper/PPtX
</commit_message>
<xml_diff>
--- a/opendesign/mockups/conference-b-deck/robustness_presentation.pptx
+++ b/opendesign/mockups/conference-b-deck/robustness_presentation.pptx
@@ -3745,7 +3745,7 @@
                         </a:defRPr>
                       </a:pPr>
                       <a:r>
-                        <a:t>0.066±0.024</a:t>
+                        <a:t>0.074±0.020</a:t>
                       </a:r>
                     </a:p>
                   </a:txBody>
@@ -3867,7 +3867,7 @@
                         </a:defRPr>
                       </a:pPr>
                       <a:r>
-                        <a:t>0.087±0.022</a:t>
+                        <a:t>0.086±0.023</a:t>
                       </a:r>
                     </a:p>
                   </a:txBody>
@@ -3989,7 +3989,7 @@
                         </a:defRPr>
                       </a:pPr>
                       <a:r>
-                        <a:t>0.104±0.019</a:t>
+                        <a:t>0.113±0.027</a:t>
                       </a:r>
                     </a:p>
                   </a:txBody>
@@ -4111,7 +4111,7 @@
                         </a:defRPr>
                       </a:pPr>
                       <a:r>
-                        <a:t>0.137±0.026</a:t>
+                        <a:t>0.159±0.021</a:t>
                       </a:r>
                     </a:p>
                   </a:txBody>
@@ -4153,7 +4153,7 @@
               </a:defRPr>
             </a:pPr>
             <a:r>
-              <a:t>All three methods comparable at H=10–30; temperature scaling underperforms at H=50</a:t>
+              <a:t>Isotonic and Platt comparable at all horizons; temperature scaling underperforms at H=30+</a:t>
             </a:r>
           </a:p>
         </p:txBody>

</xml_diff>